<commit_message>
add two more demos, update slides
</commit_message>
<xml_diff>
--- a/Using MIDI with CircuitPython Slides.pptx
+++ b/Using MIDI with CircuitPython Slides.pptx
@@ -13755,7 +13755,12 @@
             <p:ph type="ctrTitle"/>
           </p:nvPr>
         </p:nvSpPr>
-        <p:spPr/>
+        <p:spPr>
+          <a:xfrm>
+            <a:off x="902507" y="1041400"/>
+            <a:ext cx="8791575" cy="2387600"/>
+          </a:xfrm>
+        </p:spPr>
         <p:txBody>
           <a:bodyPr>
             <a:normAutofit/>
@@ -13764,20 +13769,14 @@
           <a:p>
             <a:pPr algn="ctr"/>
             <a:r>
-              <a:rPr lang="en-US" sz="5400" dirty="0">
-                <a:latin typeface="Rockwell" panose="02060603020205020403" pitchFamily="18" charset="0"/>
-              </a:rPr>
+              <a:rPr lang="en-US" sz="5400" dirty="0"/>
               <a:t>Using MIDI with </a:t>
             </a:r>
             <a:r>
-              <a:rPr lang="en-US" sz="5400" dirty="0" err="1">
-                <a:latin typeface="Rockwell" panose="02060603020205020403" pitchFamily="18" charset="0"/>
-              </a:rPr>
+              <a:rPr lang="en-US" sz="5400" dirty="0" err="1"/>
               <a:t>CircuitPython</a:t>
             </a:r>
-            <a:endParaRPr lang="en-US" sz="5400" dirty="0">
-              <a:latin typeface="Rockwell" panose="02060603020205020403" pitchFamily="18" charset="0"/>
-            </a:endParaRPr>
+            <a:endParaRPr lang="en-US" sz="5400" dirty="0"/>
           </a:p>
         </p:txBody>
       </p:sp>
@@ -13807,7 +13806,6 @@
             <a:pPr algn="ctr"/>
             <a:r>
               <a:rPr lang="en-US" sz="2400" dirty="0">
-                <a:latin typeface="Tahoma" panose="020B0604030504040204" pitchFamily="34" charset="0"/>
                 <a:ea typeface="Tahoma" panose="020B0604030504040204" pitchFamily="34" charset="0"/>
                 <a:cs typeface="Tahoma" panose="020B0604030504040204" pitchFamily="34" charset="0"/>
               </a:rPr>
@@ -13818,7 +13816,6 @@
             <a:pPr algn="ctr"/>
             <a:r>
               <a:rPr lang="en-US" sz="2400" dirty="0">
-                <a:latin typeface="Tahoma" panose="020B0604030504040204" pitchFamily="34" charset="0"/>
                 <a:ea typeface="Tahoma" panose="020B0604030504040204" pitchFamily="34" charset="0"/>
                 <a:cs typeface="Tahoma" panose="020B0604030504040204" pitchFamily="34" charset="0"/>
               </a:rPr>
@@ -13827,6 +13824,36 @@
           </a:p>
         </p:txBody>
       </p:sp>
+      <p:pic>
+        <p:nvPicPr>
+          <p:cNvPr id="5" name="Picture 4">
+            <a:extLst>
+              <a:ext uri="{FF2B5EF4-FFF2-40B4-BE49-F238E27FC236}">
+                <a16:creationId xmlns:a16="http://schemas.microsoft.com/office/drawing/2014/main" id="{ECA3D602-C083-F77B-3914-4F792798BEFA}"/>
+              </a:ext>
+            </a:extLst>
+          </p:cNvPr>
+          <p:cNvPicPr>
+            <a:picLocks noChangeAspect="1"/>
+          </p:cNvPicPr>
+          <p:nvPr/>
+        </p:nvPicPr>
+        <p:blipFill>
+          <a:blip r:embed="rId2"/>
+          <a:stretch>
+            <a:fillRect/>
+          </a:stretch>
+        </p:blipFill>
+        <p:spPr>
+          <a:xfrm>
+            <a:off x="8367742" y="1628965"/>
+            <a:ext cx="1947834" cy="2057400"/>
+          </a:xfrm>
+          <a:prstGeom prst="rect">
+            <a:avLst/>
+          </a:prstGeom>
+        </p:spPr>
+      </p:pic>
     </p:spTree>
     <p:extLst>
       <p:ext uri="{BB962C8B-B14F-4D97-AF65-F5344CB8AC3E}">
@@ -13873,9 +13900,16 @@
             <p:ph type="title"/>
           </p:nvPr>
         </p:nvSpPr>
-        <p:spPr/>
+        <p:spPr>
+          <a:xfrm>
+            <a:off x="1141410" y="4304664"/>
+            <a:ext cx="9912355" cy="819355"/>
+          </a:xfrm>
+        </p:spPr>
         <p:txBody>
-          <a:bodyPr/>
+          <a:bodyPr anchor="b">
+            <a:normAutofit/>
+          </a:bodyPr>
           <a:lstStyle/>
           <a:p>
             <a:r>
@@ -13885,12 +13919,46 @@
           </a:p>
         </p:txBody>
       </p:sp>
+      <p:pic>
+        <p:nvPicPr>
+          <p:cNvPr id="11" name="Content Placeholder 10">
+            <a:extLst>
+              <a:ext uri="{FF2B5EF4-FFF2-40B4-BE49-F238E27FC236}">
+                <a16:creationId xmlns:a16="http://schemas.microsoft.com/office/drawing/2014/main" id="{3C32DB03-BB2C-C40F-2E78-C3EA58D6F1E2}"/>
+              </a:ext>
+            </a:extLst>
+          </p:cNvPr>
+          <p:cNvPicPr>
+            <a:picLocks noGrp="1" noChangeAspect="1"/>
+          </p:cNvPicPr>
+          <p:nvPr>
+            <p:ph type="pic" idx="1"/>
+          </p:nvPr>
+        </p:nvPicPr>
+        <p:blipFill>
+          <a:blip r:embed="rId2"/>
+          <a:srcRect t="24889" b="30725"/>
+          <a:stretch>
+            <a:fillRect/>
+          </a:stretch>
+        </p:blipFill>
+        <p:spPr>
+          <a:xfrm>
+            <a:off x="1141411" y="606426"/>
+            <a:ext cx="9912354" cy="3299778"/>
+          </a:xfrm>
+          <a:prstGeom prst="rect">
+            <a:avLst/>
+          </a:prstGeom>
+          <a:noFill/>
+        </p:spPr>
+      </p:pic>
       <p:sp>
         <p:nvSpPr>
-          <p:cNvPr id="3" name="Text Placeholder 2">
+          <p:cNvPr id="18" name="Text Placeholder 3">
             <a:extLst>
               <a:ext uri="{FF2B5EF4-FFF2-40B4-BE49-F238E27FC236}">
-                <a16:creationId xmlns:a16="http://schemas.microsoft.com/office/drawing/2014/main" id="{D0250C2B-3F61-C489-8A9C-C5AF6F0990E5}"/>
+                <a16:creationId xmlns:a16="http://schemas.microsoft.com/office/drawing/2014/main" id="{F31684BE-A008-EFCD-A4B4-BA83C25A7EE1}"/>
               </a:ext>
             </a:extLst>
           </p:cNvPr>
@@ -13898,10 +13966,15 @@
             <a:spLocks noGrp="1"/>
           </p:cNvSpPr>
           <p:nvPr>
-            <p:ph type="body" idx="1"/>
+            <p:ph type="body" sz="half" idx="2"/>
           </p:nvPr>
         </p:nvSpPr>
-        <p:spPr/>
+        <p:spPr>
+          <a:xfrm>
+            <a:off x="1141364" y="5124020"/>
+            <a:ext cx="9910859" cy="682472"/>
+          </a:xfrm>
+        </p:spPr>
         <p:txBody>
           <a:bodyPr/>
           <a:lstStyle/>
@@ -15422,9 +15495,7 @@
           <a:lstStyle/>
           <a:p>
             <a:r>
-              <a:rPr lang="en-US" sz="4400" dirty="0">
-                <a:latin typeface="Rockwell" panose="02060603020205020403" pitchFamily="18" charset="0"/>
-              </a:rPr>
+              <a:rPr lang="en-US" dirty="0"/>
               <a:t>What is MIDI?</a:t>
             </a:r>
           </a:p>
@@ -15488,33 +15559,38 @@
           </a:p>
         </p:txBody>
       </p:sp>
-      <p:sp>
-        <p:nvSpPr>
-          <p:cNvPr id="4" name="Content Placeholder 3">
+      <p:pic>
+        <p:nvPicPr>
+          <p:cNvPr id="6" name="Content Placeholder 5">
             <a:extLst>
               <a:ext uri="{FF2B5EF4-FFF2-40B4-BE49-F238E27FC236}">
-                <a16:creationId xmlns:a16="http://schemas.microsoft.com/office/drawing/2014/main" id="{7424DC01-B6AB-DEA4-3AEB-71A2335B9902}"/>
+                <a16:creationId xmlns:a16="http://schemas.microsoft.com/office/drawing/2014/main" id="{6D1E34D5-1BD6-5E09-4B45-90324164B9FA}"/>
               </a:ext>
             </a:extLst>
           </p:cNvPr>
-          <p:cNvSpPr>
-            <a:spLocks noGrp="1"/>
-          </p:cNvSpPr>
+          <p:cNvPicPr>
+            <a:picLocks noGrp="1" noChangeAspect="1"/>
+          </p:cNvPicPr>
           <p:nvPr>
             <p:ph sz="half" idx="2"/>
           </p:nvPr>
-        </p:nvSpPr>
-        <p:spPr/>
-        <p:txBody>
-          <a:bodyPr>
-            <a:normAutofit/>
-          </a:bodyPr>
-          <a:lstStyle/>
-          <a:p>
-            <a:endParaRPr lang="en-US"/>
-          </a:p>
-        </p:txBody>
-      </p:sp>
+        </p:nvPicPr>
+        <p:blipFill>
+          <a:blip r:embed="rId2"/>
+          <a:stretch>
+            <a:fillRect/>
+          </a:stretch>
+        </p:blipFill>
+        <p:spPr>
+          <a:xfrm>
+            <a:off x="6172198" y="2319889"/>
+            <a:ext cx="4875213" cy="2218221"/>
+          </a:xfrm>
+          <a:prstGeom prst="rect">
+            <a:avLst/>
+          </a:prstGeom>
+        </p:spPr>
+      </p:pic>
     </p:spTree>
     <p:extLst>
       <p:ext uri="{BB962C8B-B14F-4D97-AF65-F5344CB8AC3E}">
@@ -15561,48 +15637,59 @@
             <p:ph type="title"/>
           </p:nvPr>
         </p:nvSpPr>
-        <p:spPr/>
+        <p:spPr>
+          <a:xfrm>
+            <a:off x="1141413" y="618518"/>
+            <a:ext cx="9905998" cy="1478570"/>
+          </a:xfrm>
+        </p:spPr>
         <p:txBody>
-          <a:bodyPr/>
+          <a:bodyPr anchor="ctr">
+            <a:normAutofit/>
+          </a:bodyPr>
           <a:lstStyle/>
           <a:p>
             <a:r>
-              <a:rPr lang="en-US" dirty="0">
-                <a:latin typeface="Rockwell" panose="02060603020205020403" pitchFamily="18" charset="0"/>
-              </a:rPr>
+              <a:rPr lang="en-US" dirty="0"/>
               <a:t>How MIDI is Transmitted</a:t>
             </a:r>
-            <a:endParaRPr lang="en-US" dirty="0"/>
           </a:p>
         </p:txBody>
       </p:sp>
-      <p:sp>
-        <p:nvSpPr>
-          <p:cNvPr id="3" name="Content Placeholder 2">
+      <p:pic>
+        <p:nvPicPr>
+          <p:cNvPr id="6" name="Content Placeholder 5">
             <a:extLst>
               <a:ext uri="{FF2B5EF4-FFF2-40B4-BE49-F238E27FC236}">
-                <a16:creationId xmlns:a16="http://schemas.microsoft.com/office/drawing/2014/main" id="{DD4DD591-FBD0-FCB0-6A75-BDA84AB86EFF}"/>
+                <a16:creationId xmlns:a16="http://schemas.microsoft.com/office/drawing/2014/main" id="{C4923D54-9995-9AC0-6C21-ED1C996AD931}"/>
               </a:ext>
             </a:extLst>
           </p:cNvPr>
-          <p:cNvSpPr>
-            <a:spLocks noGrp="1"/>
-          </p:cNvSpPr>
+          <p:cNvPicPr>
+            <a:picLocks noGrp="1" noChangeAspect="1"/>
+          </p:cNvPicPr>
           <p:nvPr>
             <p:ph sz="half" idx="1"/>
           </p:nvPr>
-        </p:nvSpPr>
-        <p:spPr/>
-        <p:txBody>
-          <a:bodyPr>
-            <a:normAutofit fontScale="92500" lnSpcReduction="10000"/>
-          </a:bodyPr>
-          <a:lstStyle/>
-          <a:p>
-            <a:endParaRPr lang="en-US"/>
-          </a:p>
-        </p:txBody>
-      </p:sp>
+        </p:nvPicPr>
+        <p:blipFill>
+          <a:blip r:embed="rId2"/>
+          <a:srcRect l="2461" r="20060"/>
+          <a:stretch>
+            <a:fillRect/>
+          </a:stretch>
+        </p:blipFill>
+        <p:spPr>
+          <a:xfrm>
+            <a:off x="1141410" y="2249486"/>
+            <a:ext cx="4878389" cy="3541714"/>
+          </a:xfrm>
+          <a:prstGeom prst="rect">
+            <a:avLst/>
+          </a:prstGeom>
+          <a:noFill/>
+        </p:spPr>
+      </p:pic>
       <p:sp>
         <p:nvSpPr>
           <p:cNvPr id="4" name="Content Placeholder 3">
@@ -15619,20 +15706,34 @@
             <p:ph sz="half" idx="2"/>
           </p:nvPr>
         </p:nvSpPr>
-        <p:spPr/>
+        <p:spPr>
+          <a:xfrm>
+            <a:off x="6172200" y="2249486"/>
+            <a:ext cx="4875211" cy="3541714"/>
+          </a:xfrm>
+        </p:spPr>
         <p:txBody>
           <a:bodyPr>
-            <a:normAutofit fontScale="92500" lnSpcReduction="10000"/>
+            <a:normAutofit/>
           </a:bodyPr>
           <a:lstStyle/>
           <a:p>
-            <a:r>
-              <a:rPr lang="en-US" dirty="0"/>
+            <a:pPr>
+              <a:lnSpc>
+                <a:spcPct val="110000"/>
+              </a:lnSpc>
+            </a:pPr>
+            <a:r>
+              <a:rPr lang="en-US" sz="2000" dirty="0"/>
               <a:t>Bidirectional</a:t>
             </a:r>
           </a:p>
           <a:p>
-            <a:pPr lvl="1"/>
+            <a:pPr lvl="1">
+              <a:lnSpc>
+                <a:spcPct val="110000"/>
+              </a:lnSpc>
+            </a:pPr>
             <a:r>
               <a:rPr lang="en-US" dirty="0"/>
               <a:t>MIDI in: </a:t>
@@ -15651,7 +15752,11 @@
             </a:r>
           </a:p>
           <a:p>
-            <a:pPr lvl="1"/>
+            <a:pPr lvl="1">
+              <a:lnSpc>
+                <a:spcPct val="110000"/>
+              </a:lnSpc>
+            </a:pPr>
             <a:r>
               <a:rPr lang="en-US" dirty="0"/>
               <a:t>MIDI out: </a:t>
@@ -15670,20 +15775,33 @@
             </a:r>
           </a:p>
           <a:p>
-            <a:r>
-              <a:rPr lang="en-US" b="1" dirty="0"/>
+            <a:pPr>
+              <a:lnSpc>
+                <a:spcPct val="110000"/>
+              </a:lnSpc>
+            </a:pPr>
+            <a:r>
+              <a:rPr lang="en-US" sz="2000" dirty="0"/>
               <a:t>MIDI Channels</a:t>
             </a:r>
           </a:p>
           <a:p>
-            <a:pPr lvl="1"/>
+            <a:pPr lvl="1">
+              <a:lnSpc>
+                <a:spcPct val="110000"/>
+              </a:lnSpc>
+            </a:pPr>
             <a:r>
               <a:rPr lang="en-US" dirty="0"/>
               <a:t>Messages are sent via channels, 1-16</a:t>
             </a:r>
           </a:p>
           <a:p>
-            <a:pPr lvl="1"/>
+            <a:pPr lvl="1">
+              <a:lnSpc>
+                <a:spcPct val="110000"/>
+              </a:lnSpc>
+            </a:pPr>
             <a:r>
               <a:rPr lang="en-US" dirty="0"/>
               <a:t>Allow devices to know what and who to listen to</a:t>
@@ -15765,7 +15883,12 @@
             <p:ph type="body" idx="1"/>
           </p:nvPr>
         </p:nvSpPr>
-        <p:spPr/>
+        <p:spPr>
+          <a:xfrm>
+            <a:off x="1148160" y="4148142"/>
+            <a:ext cx="3195240" cy="576262"/>
+          </a:xfrm>
+        </p:spPr>
         <p:txBody>
           <a:bodyPr/>
           <a:lstStyle/>
@@ -15777,31 +15900,56 @@
           </a:p>
         </p:txBody>
       </p:sp>
-      <p:sp>
-        <p:nvSpPr>
-          <p:cNvPr id="8" name="Picture Placeholder 7">
+      <p:pic>
+        <p:nvPicPr>
+          <p:cNvPr id="15" name="Picture Placeholder 14">
             <a:extLst>
               <a:ext uri="{FF2B5EF4-FFF2-40B4-BE49-F238E27FC236}">
-                <a16:creationId xmlns:a16="http://schemas.microsoft.com/office/drawing/2014/main" id="{D26A990B-3D8A-8F0C-B173-A81A5337D370}"/>
+                <a16:creationId xmlns:a16="http://schemas.microsoft.com/office/drawing/2014/main" id="{7CD83CC9-C01E-5DB9-1775-7AE1C21F9E0F}"/>
               </a:ext>
             </a:extLst>
           </p:cNvPr>
-          <p:cNvSpPr>
-            <a:spLocks noGrp="1"/>
-          </p:cNvSpPr>
+          <p:cNvPicPr>
+            <a:picLocks noGrp="1" noChangeAspect="1"/>
+          </p:cNvPicPr>
           <p:nvPr>
             <p:ph type="pic" idx="15"/>
           </p:nvPr>
-        </p:nvSpPr>
-        <p:spPr/>
-        <p:txBody>
-          <a:bodyPr/>
-          <a:lstStyle/>
-          <a:p>
-            <a:endParaRPr lang="en-US"/>
-          </a:p>
-        </p:txBody>
-      </p:sp>
+        </p:nvPicPr>
+        <p:blipFill>
+          <a:blip r:embed="rId2"/>
+          <a:srcRect t="7609" b="7609"/>
+          <a:stretch>
+            <a:fillRect/>
+          </a:stretch>
+        </p:blipFill>
+        <p:spPr>
+          <a:xfrm>
+            <a:off x="1144591" y="2453404"/>
+            <a:ext cx="3195240" cy="1524000"/>
+          </a:xfrm>
+          <a:prstGeom prst="round2DiagRect">
+            <a:avLst/>
+          </a:prstGeom>
+          <a:ln w="19050" cap="sq">
+            <a:solidFill>
+              <a:srgbClr val="DFE3E5">
+                <a:lumMod val="60000"/>
+                <a:lumOff val="40000"/>
+                <a:alpha val="60000"/>
+              </a:srgbClr>
+            </a:solidFill>
+            <a:miter lim="800000"/>
+          </a:ln>
+          <a:effectLst>
+            <a:outerShdw blurRad="88900" dist="38100" dir="5400000" algn="t" rotWithShape="0">
+              <a:prstClr val="black">
+                <a:alpha val="40000"/>
+              </a:prstClr>
+            </a:outerShdw>
+          </a:effectLst>
+        </p:spPr>
+      </p:pic>
       <p:sp>
         <p:nvSpPr>
           <p:cNvPr id="9" name="Text Placeholder 8">
@@ -15818,9 +15966,16 @@
             <p:ph type="body" sz="half" idx="18"/>
           </p:nvPr>
         </p:nvSpPr>
-        <p:spPr/>
+        <p:spPr>
+          <a:xfrm>
+            <a:off x="1148160" y="4724404"/>
+            <a:ext cx="3195240" cy="817843"/>
+          </a:xfrm>
+        </p:spPr>
         <p:txBody>
-          <a:bodyPr/>
+          <a:bodyPr>
+            <a:normAutofit fontScale="92500"/>
+          </a:bodyPr>
           <a:lstStyle/>
           <a:p>
             <a:pPr marL="285750" indent="-285750">
@@ -15830,6 +15985,16 @@
             <a:r>
               <a:rPr lang="en-US" dirty="0"/>
               <a:t>The original MIDI connector</a:t>
+            </a:r>
+          </a:p>
+          <a:p>
+            <a:pPr marL="285750" indent="-285750">
+              <a:buFont typeface="Arial" panose="020B0604020202020204" pitchFamily="34" charset="0"/>
+              <a:buChar char="•"/>
+            </a:pPr>
+            <a:r>
+              <a:rPr lang="en-US" dirty="0"/>
+              <a:t>Different circuit for MIDI in and MIDI out</a:t>
             </a:r>
           </a:p>
         </p:txBody>
@@ -15850,7 +16015,12 @@
             <p:ph type="body" sz="quarter" idx="3"/>
           </p:nvPr>
         </p:nvSpPr>
-        <p:spPr/>
+        <p:spPr>
+          <a:xfrm>
+            <a:off x="4495800" y="4148142"/>
+            <a:ext cx="3200400" cy="576262"/>
+          </a:xfrm>
+        </p:spPr>
         <p:txBody>
           <a:bodyPr/>
           <a:lstStyle/>
@@ -15862,31 +16032,56 @@
           </a:p>
         </p:txBody>
       </p:sp>
-      <p:sp>
-        <p:nvSpPr>
-          <p:cNvPr id="12" name="Picture Placeholder 11">
+      <p:pic>
+        <p:nvPicPr>
+          <p:cNvPr id="17" name="Picture Placeholder 16">
             <a:extLst>
               <a:ext uri="{FF2B5EF4-FFF2-40B4-BE49-F238E27FC236}">
-                <a16:creationId xmlns:a16="http://schemas.microsoft.com/office/drawing/2014/main" id="{EE243638-66AD-974A-6A2F-E45F4F5CB698}"/>
+                <a16:creationId xmlns:a16="http://schemas.microsoft.com/office/drawing/2014/main" id="{840BBBB4-FDA9-1F4A-B2EA-32D5E696786C}"/>
               </a:ext>
             </a:extLst>
           </p:cNvPr>
-          <p:cNvSpPr>
-            <a:spLocks noGrp="1"/>
-          </p:cNvSpPr>
+          <p:cNvPicPr>
+            <a:picLocks noGrp="1" noChangeAspect="1"/>
+          </p:cNvPicPr>
           <p:nvPr>
             <p:ph type="pic" idx="21"/>
           </p:nvPr>
-        </p:nvSpPr>
-        <p:spPr/>
-        <p:txBody>
-          <a:bodyPr/>
-          <a:lstStyle/>
-          <a:p>
-            <a:endParaRPr lang="en-US"/>
-          </a:p>
-        </p:txBody>
-      </p:sp>
+        </p:nvPicPr>
+        <p:blipFill>
+          <a:blip r:embed="rId3"/>
+          <a:srcRect t="7651" b="7651"/>
+          <a:stretch>
+            <a:fillRect/>
+          </a:stretch>
+        </p:blipFill>
+        <p:spPr>
+          <a:xfrm>
+            <a:off x="4492231" y="2453404"/>
+            <a:ext cx="3198940" cy="1524000"/>
+          </a:xfrm>
+          <a:prstGeom prst="round2DiagRect">
+            <a:avLst/>
+          </a:prstGeom>
+          <a:ln w="19050" cap="sq">
+            <a:solidFill>
+              <a:srgbClr val="DFE3E5">
+                <a:lumMod val="60000"/>
+                <a:lumOff val="40000"/>
+                <a:alpha val="60000"/>
+              </a:srgbClr>
+            </a:solidFill>
+            <a:miter lim="800000"/>
+          </a:ln>
+          <a:effectLst>
+            <a:outerShdw blurRad="88900" dist="38100" dir="5400000" algn="t" rotWithShape="0">
+              <a:prstClr val="black">
+                <a:alpha val="40000"/>
+              </a:prstClr>
+            </a:outerShdw>
+          </a:effectLst>
+        </p:spPr>
+      </p:pic>
       <p:sp>
         <p:nvSpPr>
           <p:cNvPr id="10" name="Text Placeholder 9">
@@ -15905,13 +16100,13 @@
         </p:nvSpPr>
         <p:spPr>
           <a:xfrm>
-            <a:off x="4487593" y="4980856"/>
+            <a:off x="4494340" y="4724402"/>
             <a:ext cx="3200400" cy="1523997"/>
           </a:xfrm>
         </p:spPr>
         <p:txBody>
           <a:bodyPr>
-            <a:normAutofit/>
+            <a:normAutofit lnSpcReduction="10000"/>
           </a:bodyPr>
           <a:lstStyle/>
           <a:p>
@@ -15933,6 +16128,23 @@
               <a:rPr lang="en-US" dirty="0"/>
               <a:t>Small form factor, but not always standardized</a:t>
             </a:r>
+          </a:p>
+          <a:p>
+            <a:pPr marL="285750" indent="-285750">
+              <a:buFont typeface="Arial" panose="020B0604020202020204" pitchFamily="34" charset="0"/>
+              <a:buChar char="•"/>
+            </a:pPr>
+            <a:r>
+              <a:rPr lang="en-US" dirty="0"/>
+              <a:t>Different circuit for MIDI in and MIDI out</a:t>
+            </a:r>
+          </a:p>
+          <a:p>
+            <a:pPr marL="285750" indent="-285750">
+              <a:buFont typeface="Arial" panose="020B0604020202020204" pitchFamily="34" charset="0"/>
+              <a:buChar char="•"/>
+            </a:pPr>
+            <a:endParaRPr lang="en-US" dirty="0"/>
           </a:p>
         </p:txBody>
       </p:sp>
@@ -15952,7 +16164,12 @@
             <p:ph type="body" sz="quarter" idx="13"/>
           </p:nvPr>
         </p:nvSpPr>
-        <p:spPr/>
+        <p:spPr>
+          <a:xfrm>
+            <a:off x="7859314" y="4148141"/>
+            <a:ext cx="3190741" cy="576262"/>
+          </a:xfrm>
+        </p:spPr>
         <p:txBody>
           <a:bodyPr/>
           <a:lstStyle/>
@@ -15964,31 +16181,56 @@
           </a:p>
         </p:txBody>
       </p:sp>
-      <p:sp>
-        <p:nvSpPr>
-          <p:cNvPr id="13" name="Picture Placeholder 12">
+      <p:pic>
+        <p:nvPicPr>
+          <p:cNvPr id="19" name="Picture Placeholder 18">
             <a:extLst>
               <a:ext uri="{FF2B5EF4-FFF2-40B4-BE49-F238E27FC236}">
-                <a16:creationId xmlns:a16="http://schemas.microsoft.com/office/drawing/2014/main" id="{727BA40F-438D-F514-67B2-FAF6F2F82F37}"/>
+                <a16:creationId xmlns:a16="http://schemas.microsoft.com/office/drawing/2014/main" id="{FCCE9545-4CBC-80D9-B7FB-D4CF6A84BFB8}"/>
               </a:ext>
             </a:extLst>
           </p:cNvPr>
-          <p:cNvSpPr>
-            <a:spLocks noGrp="1"/>
-          </p:cNvSpPr>
+          <p:cNvPicPr>
+            <a:picLocks noGrp="1" noChangeAspect="1"/>
+          </p:cNvPicPr>
           <p:nvPr>
             <p:ph type="pic" idx="22"/>
           </p:nvPr>
-        </p:nvSpPr>
-        <p:spPr/>
-        <p:txBody>
-          <a:bodyPr/>
-          <a:lstStyle/>
-          <a:p>
-            <a:endParaRPr lang="en-US"/>
-          </a:p>
-        </p:txBody>
-      </p:sp>
+        </p:nvPicPr>
+        <p:blipFill>
+          <a:blip r:embed="rId4"/>
+          <a:srcRect t="18228" b="18228"/>
+          <a:stretch>
+            <a:fillRect/>
+          </a:stretch>
+        </p:blipFill>
+        <p:spPr>
+          <a:xfrm>
+            <a:off x="7855620" y="2453404"/>
+            <a:ext cx="3194969" cy="1524000"/>
+          </a:xfrm>
+          <a:prstGeom prst="round2DiagRect">
+            <a:avLst/>
+          </a:prstGeom>
+          <a:ln w="19050" cap="sq">
+            <a:solidFill>
+              <a:srgbClr val="DFE3E5">
+                <a:lumMod val="60000"/>
+                <a:lumOff val="40000"/>
+                <a:alpha val="60000"/>
+              </a:srgbClr>
+            </a:solidFill>
+            <a:miter lim="800000"/>
+          </a:ln>
+          <a:effectLst>
+            <a:outerShdw blurRad="88900" dist="38100" dir="5400000" algn="t" rotWithShape="0">
+              <a:prstClr val="black">
+                <a:alpha val="40000"/>
+              </a:prstClr>
+            </a:outerShdw>
+          </a:effectLst>
+        </p:spPr>
+      </p:pic>
       <p:sp>
         <p:nvSpPr>
           <p:cNvPr id="11" name="Text Placeholder 10">
@@ -16007,7 +16249,7 @@
         </p:nvSpPr>
         <p:spPr>
           <a:xfrm>
-            <a:off x="7852442" y="4980854"/>
+            <a:off x="7859189" y="4724400"/>
             <a:ext cx="3194968" cy="1524000"/>
           </a:xfrm>
         </p:spPr>
@@ -16092,9 +16334,16 @@
             <p:ph type="title"/>
           </p:nvPr>
         </p:nvSpPr>
-        <p:spPr/>
+        <p:spPr>
+          <a:xfrm>
+            <a:off x="1141413" y="618518"/>
+            <a:ext cx="9905998" cy="1478570"/>
+          </a:xfrm>
+        </p:spPr>
         <p:txBody>
-          <a:bodyPr/>
+          <a:bodyPr anchor="ctr">
+            <a:normAutofit/>
+          </a:bodyPr>
           <a:lstStyle/>
           <a:p>
             <a:r>
@@ -16120,9 +16369,16 @@
             <p:ph sz="half" idx="1"/>
           </p:nvPr>
         </p:nvSpPr>
-        <p:spPr/>
+        <p:spPr>
+          <a:xfrm>
+            <a:off x="1141410" y="2249486"/>
+            <a:ext cx="4878389" cy="3541714"/>
+          </a:xfrm>
+        </p:spPr>
         <p:txBody>
-          <a:bodyPr/>
+          <a:bodyPr>
+            <a:normAutofit/>
+          </a:bodyPr>
           <a:lstStyle/>
           <a:p>
             <a:r>
@@ -16144,42 +16400,51 @@
           <a:p>
             <a:pPr lvl="1"/>
             <a:r>
-              <a:rPr lang="en-US" dirty="0"/>
+              <a:rPr lang="en-US" sz="2400"/>
               <a:t>Can be used on the Circuit Playground </a:t>
             </a:r>
             <a:r>
-              <a:rPr lang="en-US" dirty="0" err="1"/>
+              <a:rPr lang="en-US" sz="2400" err="1"/>
               <a:t>Bluefruit</a:t>
             </a:r>
-            <a:endParaRPr lang="en-US" dirty="0"/>
+            <a:endParaRPr lang="en-US" sz="2400"/>
           </a:p>
         </p:txBody>
       </p:sp>
-      <p:sp>
-        <p:nvSpPr>
-          <p:cNvPr id="4" name="Content Placeholder 3">
+      <p:pic>
+        <p:nvPicPr>
+          <p:cNvPr id="6" name="Content Placeholder 5">
             <a:extLst>
               <a:ext uri="{FF2B5EF4-FFF2-40B4-BE49-F238E27FC236}">
-                <a16:creationId xmlns:a16="http://schemas.microsoft.com/office/drawing/2014/main" id="{22CF9DE2-FB75-01B1-5957-FAD08A7632C0}"/>
+                <a16:creationId xmlns:a16="http://schemas.microsoft.com/office/drawing/2014/main" id="{797DAD5C-0819-A043-50FA-C15E824C23A8}"/>
               </a:ext>
             </a:extLst>
           </p:cNvPr>
-          <p:cNvSpPr>
-            <a:spLocks noGrp="1"/>
-          </p:cNvSpPr>
+          <p:cNvPicPr>
+            <a:picLocks noGrp="1" noChangeAspect="1"/>
+          </p:cNvPicPr>
           <p:nvPr>
             <p:ph sz="half" idx="2"/>
           </p:nvPr>
-        </p:nvSpPr>
-        <p:spPr/>
-        <p:txBody>
-          <a:bodyPr/>
-          <a:lstStyle/>
-          <a:p>
-            <a:endParaRPr lang="en-US"/>
-          </a:p>
-        </p:txBody>
-      </p:sp>
+        </p:nvPicPr>
+        <p:blipFill>
+          <a:blip r:embed="rId2"/>
+          <a:srcRect r="22571"/>
+          <a:stretch>
+            <a:fillRect/>
+          </a:stretch>
+        </p:blipFill>
+        <p:spPr>
+          <a:xfrm>
+            <a:off x="6172200" y="2249486"/>
+            <a:ext cx="4875211" cy="3541714"/>
+          </a:xfrm>
+          <a:prstGeom prst="rect">
+            <a:avLst/>
+          </a:prstGeom>
+          <a:noFill/>
+        </p:spPr>
+      </p:pic>
     </p:spTree>
     <p:extLst>
       <p:ext uri="{BB962C8B-B14F-4D97-AF65-F5344CB8AC3E}">
@@ -16238,31 +16503,38 @@
           </a:p>
         </p:txBody>
       </p:sp>
-      <p:sp>
-        <p:nvSpPr>
-          <p:cNvPr id="3" name="Text Placeholder 2">
+      <p:pic>
+        <p:nvPicPr>
+          <p:cNvPr id="6" name="Content Placeholder 5">
             <a:extLst>
               <a:ext uri="{FF2B5EF4-FFF2-40B4-BE49-F238E27FC236}">
-                <a16:creationId xmlns:a16="http://schemas.microsoft.com/office/drawing/2014/main" id="{BDA33875-5AD1-1760-3AB3-15FD41CB3C36}"/>
+                <a16:creationId xmlns:a16="http://schemas.microsoft.com/office/drawing/2014/main" id="{02267CC5-0592-FA60-431E-2F8C93A0A929}"/>
               </a:ext>
             </a:extLst>
           </p:cNvPr>
-          <p:cNvSpPr>
-            <a:spLocks noGrp="1"/>
-          </p:cNvSpPr>
-          <p:nvPr>
-            <p:ph type="body" idx="1"/>
-          </p:nvPr>
-        </p:nvSpPr>
-        <p:spPr/>
-        <p:txBody>
-          <a:bodyPr/>
-          <a:lstStyle/>
-          <a:p>
-            <a:endParaRPr lang="en-US"/>
-          </a:p>
-        </p:txBody>
-      </p:sp>
+          <p:cNvPicPr>
+            <a:picLocks noGrp="1" noChangeAspect="1"/>
+          </p:cNvPicPr>
+          <p:nvPr>
+            <p:ph idx="1"/>
+          </p:nvPr>
+        </p:nvPicPr>
+        <p:blipFill>
+          <a:blip r:embed="rId2"/>
+          <a:stretch>
+            <a:fillRect/>
+          </a:stretch>
+        </p:blipFill>
+        <p:spPr>
+          <a:xfrm>
+            <a:off x="4189413" y="2591594"/>
+            <a:ext cx="3810000" cy="2857500"/>
+          </a:xfrm>
+          <a:prstGeom prst="rect">
+            <a:avLst/>
+          </a:prstGeom>
+        </p:spPr>
+      </p:pic>
     </p:spTree>
     <p:extLst>
       <p:ext uri="{BB962C8B-B14F-4D97-AF65-F5344CB8AC3E}">
@@ -16309,9 +16581,16 @@
             <p:ph type="title"/>
           </p:nvPr>
         </p:nvSpPr>
-        <p:spPr/>
+        <p:spPr>
+          <a:xfrm>
+            <a:off x="1141413" y="618518"/>
+            <a:ext cx="9905998" cy="1478570"/>
+          </a:xfrm>
+        </p:spPr>
         <p:txBody>
-          <a:bodyPr/>
+          <a:bodyPr anchor="ctr">
+            <a:normAutofit/>
+          </a:bodyPr>
           <a:lstStyle/>
           <a:p>
             <a:r>
@@ -16346,83 +16625,122 @@
             <p:ph sz="half" idx="1"/>
           </p:nvPr>
         </p:nvSpPr>
-        <p:spPr/>
+        <p:spPr>
+          <a:xfrm>
+            <a:off x="1141410" y="2249486"/>
+            <a:ext cx="4878389" cy="3541714"/>
+          </a:xfrm>
+        </p:spPr>
         <p:txBody>
           <a:bodyPr>
             <a:normAutofit/>
           </a:bodyPr>
           <a:lstStyle/>
           <a:p>
-            <a:r>
-              <a:rPr lang="en-US" dirty="0"/>
+            <a:pPr>
+              <a:lnSpc>
+                <a:spcPct val="110000"/>
+              </a:lnSpc>
+            </a:pPr>
+            <a:r>
+              <a:rPr lang="en-US" sz="2200"/>
               <a:t>How notes are played</a:t>
             </a:r>
           </a:p>
           <a:p>
-            <a:pPr lvl="1"/>
-            <a:r>
-              <a:rPr lang="en-US" dirty="0"/>
+            <a:pPr lvl="1">
+              <a:lnSpc>
+                <a:spcPct val="110000"/>
+              </a:lnSpc>
+            </a:pPr>
+            <a:r>
+              <a:rPr lang="en-US" sz="2200"/>
               <a:t>i.e. when you play a piano keyboard</a:t>
             </a:r>
           </a:p>
           <a:p>
-            <a:r>
-              <a:rPr lang="en-US" dirty="0"/>
+            <a:pPr>
+              <a:lnSpc>
+                <a:spcPct val="110000"/>
+              </a:lnSpc>
+            </a:pPr>
+            <a:r>
+              <a:rPr lang="en-US" sz="2200"/>
               <a:t>Notes in MIDI are numbered 1-127</a:t>
             </a:r>
           </a:p>
           <a:p>
-            <a:pPr lvl="1"/>
-            <a:r>
-              <a:rPr lang="en-US" dirty="0"/>
+            <a:pPr lvl="1">
+              <a:lnSpc>
+                <a:spcPct val="110000"/>
+              </a:lnSpc>
+            </a:pPr>
+            <a:r>
+              <a:rPr lang="en-US" sz="2200"/>
               <a:t>Ex: C4/Middle C is 60</a:t>
             </a:r>
           </a:p>
           <a:p>
-            <a:pPr lvl="1"/>
-            <a:r>
-              <a:rPr lang="en-US" cap="all" dirty="0">
+            <a:pPr lvl="1">
+              <a:lnSpc>
+                <a:spcPct val="110000"/>
+              </a:lnSpc>
+            </a:pPr>
+            <a:r>
+              <a:rPr lang="en-US" sz="2200" cap="all">
                 <a:hlinkClick r:id="rId3"/>
               </a:rPr>
               <a:t>MIDI note numbers and center frequencies</a:t>
             </a:r>
-            <a:endParaRPr lang="en-US" dirty="0"/>
-          </a:p>
-          <a:p>
-            <a:r>
-              <a:rPr lang="en-US" dirty="0"/>
+            <a:endParaRPr lang="en-US" sz="2200"/>
+          </a:p>
+          <a:p>
+            <a:pPr>
+              <a:lnSpc>
+                <a:spcPct val="110000"/>
+              </a:lnSpc>
+            </a:pPr>
+            <a:r>
+              <a:rPr lang="en-US" sz="2200"/>
               <a:t>Velocity: strength, force, loudness</a:t>
             </a:r>
           </a:p>
         </p:txBody>
       </p:sp>
-      <p:sp>
-        <p:nvSpPr>
-          <p:cNvPr id="4" name="Content Placeholder 3">
+      <p:pic>
+        <p:nvPicPr>
+          <p:cNvPr id="6" name="Content Placeholder 5">
             <a:extLst>
               <a:ext uri="{FF2B5EF4-FFF2-40B4-BE49-F238E27FC236}">
-                <a16:creationId xmlns:a16="http://schemas.microsoft.com/office/drawing/2014/main" id="{40649F37-6223-C243-E6E6-09ABDA8371EC}"/>
+                <a16:creationId xmlns:a16="http://schemas.microsoft.com/office/drawing/2014/main" id="{C3646D60-73C2-3279-64E7-B055EF392458}"/>
               </a:ext>
             </a:extLst>
           </p:cNvPr>
-          <p:cNvSpPr>
-            <a:spLocks noGrp="1"/>
-          </p:cNvSpPr>
+          <p:cNvPicPr>
+            <a:picLocks noGrp="1" noChangeAspect="1"/>
+          </p:cNvPicPr>
           <p:nvPr>
             <p:ph sz="half" idx="2"/>
           </p:nvPr>
-        </p:nvSpPr>
-        <p:spPr/>
-        <p:txBody>
-          <a:bodyPr>
-            <a:normAutofit/>
-          </a:bodyPr>
-          <a:lstStyle/>
-          <a:p>
-            <a:endParaRPr lang="en-US"/>
-          </a:p>
-        </p:txBody>
-      </p:sp>
+        </p:nvPicPr>
+        <p:blipFill>
+          <a:blip r:embed="rId4"/>
+          <a:srcRect l="15995" r="6576"/>
+          <a:stretch>
+            <a:fillRect/>
+          </a:stretch>
+        </p:blipFill>
+        <p:spPr>
+          <a:xfrm>
+            <a:off x="6172200" y="2249486"/>
+            <a:ext cx="4875211" cy="3541714"/>
+          </a:xfrm>
+          <a:prstGeom prst="rect">
+            <a:avLst/>
+          </a:prstGeom>
+          <a:noFill/>
+        </p:spPr>
+      </p:pic>
     </p:spTree>
     <p:extLst>
       <p:ext uri="{BB962C8B-B14F-4D97-AF65-F5344CB8AC3E}">
@@ -16475,40 +16793,44 @@
           <a:lstStyle/>
           <a:p>
             <a:r>
-              <a:rPr lang="en-US" dirty="0" err="1"/>
-              <a:t>ControlChange</a:t>
-            </a:r>
-            <a:endParaRPr lang="en-US" dirty="0"/>
+              <a:rPr lang="en-US" dirty="0"/>
+              <a:t>Control Change (CC)</a:t>
+            </a:r>
           </a:p>
         </p:txBody>
       </p:sp>
-      <p:sp>
-        <p:nvSpPr>
-          <p:cNvPr id="3" name="Content Placeholder 2">
+      <p:pic>
+        <p:nvPicPr>
+          <p:cNvPr id="6" name="Content Placeholder 5">
             <a:extLst>
               <a:ext uri="{FF2B5EF4-FFF2-40B4-BE49-F238E27FC236}">
-                <a16:creationId xmlns:a16="http://schemas.microsoft.com/office/drawing/2014/main" id="{1D1832C3-B558-7CEC-4CCB-94297B5906BB}"/>
+                <a16:creationId xmlns:a16="http://schemas.microsoft.com/office/drawing/2014/main" id="{E3B2DBD9-3C6F-A0F1-20BE-FC51E141757F}"/>
               </a:ext>
             </a:extLst>
           </p:cNvPr>
-          <p:cNvSpPr>
-            <a:spLocks noGrp="1"/>
-          </p:cNvSpPr>
+          <p:cNvPicPr>
+            <a:picLocks noGrp="1" noChangeAspect="1"/>
+          </p:cNvPicPr>
           <p:nvPr>
             <p:ph sz="half" idx="1"/>
           </p:nvPr>
-        </p:nvSpPr>
-        <p:spPr/>
-        <p:txBody>
-          <a:bodyPr>
-            <a:normAutofit/>
-          </a:bodyPr>
-          <a:lstStyle/>
-          <a:p>
-            <a:endParaRPr lang="en-US"/>
-          </a:p>
-        </p:txBody>
-      </p:sp>
+        </p:nvPicPr>
+        <p:blipFill>
+          <a:blip r:embed="rId2"/>
+          <a:stretch>
+            <a:fillRect/>
+          </a:stretch>
+        </p:blipFill>
+        <p:spPr>
+          <a:xfrm>
+            <a:off x="1141413" y="2648298"/>
+            <a:ext cx="4878387" cy="2744092"/>
+          </a:xfrm>
+          <a:prstGeom prst="rect">
+            <a:avLst/>
+          </a:prstGeom>
+        </p:spPr>
+      </p:pic>
       <p:sp>
         <p:nvSpPr>
           <p:cNvPr id="4" name="Content Placeholder 3">
@@ -16554,7 +16876,7 @@
             <a:pPr lvl="1"/>
             <a:r>
               <a:rPr lang="en-US" dirty="0">
-                <a:hlinkClick r:id="rId2"/>
+                <a:hlinkClick r:id="rId3"/>
               </a:rPr>
               <a:t>CC Message table</a:t>
             </a:r>

</xml_diff>

<commit_message>
add midi thru to web app
</commit_message>
<xml_diff>
--- a/Using MIDI with CircuitPython Slides.pptx
+++ b/Using MIDI with CircuitPython Slides.pptx
@@ -232,7 +232,7 @@
           <a:p>
             <a:fld id="{2B85766F-5EC0-4797-B4D1-777FCB005B11}" type="datetimeFigureOut">
               <a:rPr lang="en-US" smtClean="0"/>
-              <a:t>9/24/2026</a:t>
+              <a:t>10/2/2026</a:t>
             </a:fld>
             <a:endParaRPr lang="en-US" dirty="0"/>
           </a:p>
@@ -409,7 +409,7 @@
           <a:p>
             <a:fld id="{B2B4B5EC-152C-4627-80C0-63B10D5574EF}" type="datetimeFigureOut">
               <a:rPr lang="en-US" smtClean="0"/>
-              <a:t>9/24/2026</a:t>
+              <a:t>9/30/2026</a:t>
             </a:fld>
             <a:endParaRPr lang="en-US" dirty="0"/>
           </a:p>
@@ -836,7 +836,7 @@
           <a:noFill/>
           <a:extLst>
             <a:ext uri="{909E8E84-426E-40dd-AFC4-6F175D3DCCD1}">
-              <a14:hiddenFill xmlns="" xmlns:a14="http://schemas.microsoft.com/office/drawing/2010/main">
+              <a14:hiddenFill xmlns:a14="http://schemas.microsoft.com/office/drawing/2010/main" xmlns="">
                 <a:solidFill>
                   <a:srgbClr val="FFFFFF"/>
                 </a:solidFill>
@@ -895,7 +895,7 @@
             </a:ln>
             <a:extLst>
               <a:ext uri="{91240B29-F687-4f45-9708-019B960494DF}">
-                <a14:hiddenLine xmlns="" xmlns:a14="http://schemas.microsoft.com/office/drawing/2010/main" w="9525">
+                <a14:hiddenLine xmlns:a14="http://schemas.microsoft.com/office/drawing/2010/main" xmlns="" w="9525">
                   <a:solidFill>
                     <a:srgbClr val="000000"/>
                   </a:solidFill>
@@ -992,7 +992,7 @@
             </a:ln>
             <a:extLst>
               <a:ext uri="{91240B29-F687-4f45-9708-019B960494DF}">
-                <a14:hiddenLine xmlns="" xmlns:a14="http://schemas.microsoft.com/office/drawing/2010/main" w="9525">
+                <a14:hiddenLine xmlns:a14="http://schemas.microsoft.com/office/drawing/2010/main" xmlns="" w="9525">
                   <a:solidFill>
                     <a:srgbClr val="000000"/>
                   </a:solidFill>
@@ -1089,7 +1089,7 @@
             </a:ln>
             <a:extLst>
               <a:ext uri="{91240B29-F687-4f45-9708-019B960494DF}">
-                <a14:hiddenLine xmlns="" xmlns:a14="http://schemas.microsoft.com/office/drawing/2010/main" w="9525">
+                <a14:hiddenLine xmlns:a14="http://schemas.microsoft.com/office/drawing/2010/main" xmlns="" w="9525">
                   <a:solidFill>
                     <a:srgbClr val="000000"/>
                   </a:solidFill>
@@ -1130,7 +1130,7 @@
             </a:ln>
             <a:extLst>
               <a:ext uri="{91240B29-F687-4f45-9708-019B960494DF}">
-                <a14:hiddenLine xmlns="" xmlns:a14="http://schemas.microsoft.com/office/drawing/2010/main" w="9525">
+                <a14:hiddenLine xmlns:a14="http://schemas.microsoft.com/office/drawing/2010/main" xmlns="" w="9525">
                   <a:solidFill>
                     <a:srgbClr val="000000"/>
                   </a:solidFill>
@@ -1227,7 +1227,7 @@
             </a:ln>
             <a:extLst>
               <a:ext uri="{91240B29-F687-4f45-9708-019B960494DF}">
-                <a14:hiddenLine xmlns="" xmlns:a14="http://schemas.microsoft.com/office/drawing/2010/main" w="9525">
+                <a14:hiddenLine xmlns:a14="http://schemas.microsoft.com/office/drawing/2010/main" xmlns="" w="9525">
                   <a:solidFill>
                     <a:srgbClr val="000000"/>
                   </a:solidFill>
@@ -1296,7 +1296,7 @@
             </a:ln>
             <a:extLst>
               <a:ext uri="{91240B29-F687-4f45-9708-019B960494DF}">
-                <a14:hiddenLine xmlns="" xmlns:a14="http://schemas.microsoft.com/office/drawing/2010/main" w="9525">
+                <a14:hiddenLine xmlns:a14="http://schemas.microsoft.com/office/drawing/2010/main" xmlns="" w="9525">
                   <a:solidFill>
                     <a:srgbClr val="000000"/>
                   </a:solidFill>
@@ -1365,7 +1365,7 @@
             </a:ln>
             <a:extLst>
               <a:ext uri="{91240B29-F687-4f45-9708-019B960494DF}">
-                <a14:hiddenLine xmlns="" xmlns:a14="http://schemas.microsoft.com/office/drawing/2010/main" w="9525">
+                <a14:hiddenLine xmlns:a14="http://schemas.microsoft.com/office/drawing/2010/main" xmlns="" w="9525">
                   <a:solidFill>
                     <a:srgbClr val="000000"/>
                   </a:solidFill>
@@ -1462,7 +1462,7 @@
             </a:ln>
             <a:extLst>
               <a:ext uri="{91240B29-F687-4f45-9708-019B960494DF}">
-                <a14:hiddenLine xmlns="" xmlns:a14="http://schemas.microsoft.com/office/drawing/2010/main" w="9525">
+                <a14:hiddenLine xmlns:a14="http://schemas.microsoft.com/office/drawing/2010/main" xmlns="" w="9525">
                   <a:solidFill>
                     <a:srgbClr val="000000"/>
                   </a:solidFill>
@@ -1531,7 +1531,7 @@
             </a:ln>
             <a:extLst>
               <a:ext uri="{91240B29-F687-4f45-9708-019B960494DF}">
-                <a14:hiddenLine xmlns="" xmlns:a14="http://schemas.microsoft.com/office/drawing/2010/main" w="9525">
+                <a14:hiddenLine xmlns:a14="http://schemas.microsoft.com/office/drawing/2010/main" xmlns="" w="9525">
                   <a:solidFill>
                     <a:srgbClr val="000000"/>
                   </a:solidFill>
@@ -1600,7 +1600,7 @@
             </a:ln>
             <a:extLst>
               <a:ext uri="{91240B29-F687-4f45-9708-019B960494DF}">
-                <a14:hiddenLine xmlns="" xmlns:a14="http://schemas.microsoft.com/office/drawing/2010/main" w="9525">
+                <a14:hiddenLine xmlns:a14="http://schemas.microsoft.com/office/drawing/2010/main" xmlns="" w="9525">
                   <a:solidFill>
                     <a:srgbClr val="000000"/>
                   </a:solidFill>
@@ -1697,7 +1697,7 @@
             </a:ln>
             <a:extLst>
               <a:ext uri="{91240B29-F687-4f45-9708-019B960494DF}">
-                <a14:hiddenLine xmlns="" xmlns:a14="http://schemas.microsoft.com/office/drawing/2010/main" w="9525">
+                <a14:hiddenLine xmlns:a14="http://schemas.microsoft.com/office/drawing/2010/main" xmlns="" w="9525">
                   <a:solidFill>
                     <a:srgbClr val="000000"/>
                   </a:solidFill>
@@ -1794,7 +1794,7 @@
             </a:ln>
             <a:extLst>
               <a:ext uri="{91240B29-F687-4f45-9708-019B960494DF}">
-                <a14:hiddenLine xmlns="" xmlns:a14="http://schemas.microsoft.com/office/drawing/2010/main" w="9525">
+                <a14:hiddenLine xmlns:a14="http://schemas.microsoft.com/office/drawing/2010/main" xmlns="" w="9525">
                   <a:solidFill>
                     <a:srgbClr val="000000"/>
                   </a:solidFill>
@@ -1863,7 +1863,7 @@
             </a:ln>
             <a:extLst>
               <a:ext uri="{91240B29-F687-4f45-9708-019B960494DF}">
-                <a14:hiddenLine xmlns="" xmlns:a14="http://schemas.microsoft.com/office/drawing/2010/main" w="9525">
+                <a14:hiddenLine xmlns:a14="http://schemas.microsoft.com/office/drawing/2010/main" xmlns="" w="9525">
                   <a:solidFill>
                     <a:srgbClr val="000000"/>
                   </a:solidFill>
@@ -1980,7 +1980,7 @@
             </a:ln>
             <a:extLst>
               <a:ext uri="{91240B29-F687-4f45-9708-019B960494DF}">
-                <a14:hiddenLine xmlns="" xmlns:a14="http://schemas.microsoft.com/office/drawing/2010/main" w="9525">
+                <a14:hiddenLine xmlns:a14="http://schemas.microsoft.com/office/drawing/2010/main" xmlns="" w="9525">
                   <a:solidFill>
                     <a:srgbClr val="000000"/>
                   </a:solidFill>
@@ -2049,7 +2049,7 @@
             </a:ln>
             <a:extLst>
               <a:ext uri="{91240B29-F687-4f45-9708-019B960494DF}">
-                <a14:hiddenLine xmlns="" xmlns:a14="http://schemas.microsoft.com/office/drawing/2010/main" w="9525">
+                <a14:hiddenLine xmlns:a14="http://schemas.microsoft.com/office/drawing/2010/main" xmlns="" w="9525">
                   <a:solidFill>
                     <a:srgbClr val="000000"/>
                   </a:solidFill>
@@ -2146,7 +2146,7 @@
             </a:ln>
             <a:extLst>
               <a:ext uri="{91240B29-F687-4f45-9708-019B960494DF}">
-                <a14:hiddenLine xmlns="" xmlns:a14="http://schemas.microsoft.com/office/drawing/2010/main" w="9525">
+                <a14:hiddenLine xmlns:a14="http://schemas.microsoft.com/office/drawing/2010/main" xmlns="" w="9525">
                   <a:solidFill>
                     <a:srgbClr val="000000"/>
                   </a:solidFill>
@@ -2243,7 +2243,7 @@
             </a:ln>
             <a:extLst>
               <a:ext uri="{91240B29-F687-4f45-9708-019B960494DF}">
-                <a14:hiddenLine xmlns="" xmlns:a14="http://schemas.microsoft.com/office/drawing/2010/main" w="9525">
+                <a14:hiddenLine xmlns:a14="http://schemas.microsoft.com/office/drawing/2010/main" xmlns="" w="9525">
                   <a:solidFill>
                     <a:srgbClr val="000000"/>
                   </a:solidFill>
@@ -2312,7 +2312,7 @@
             </a:ln>
             <a:extLst>
               <a:ext uri="{91240B29-F687-4f45-9708-019B960494DF}">
-                <a14:hiddenLine xmlns="" xmlns:a14="http://schemas.microsoft.com/office/drawing/2010/main" w="9525">
+                <a14:hiddenLine xmlns:a14="http://schemas.microsoft.com/office/drawing/2010/main" xmlns="" w="9525">
                   <a:solidFill>
                     <a:srgbClr val="000000"/>
                   </a:solidFill>
@@ -2409,7 +2409,7 @@
             </a:ln>
             <a:extLst>
               <a:ext uri="{91240B29-F687-4f45-9708-019B960494DF}">
-                <a14:hiddenLine xmlns="" xmlns:a14="http://schemas.microsoft.com/office/drawing/2010/main" w="9525">
+                <a14:hiddenLine xmlns:a14="http://schemas.microsoft.com/office/drawing/2010/main" xmlns="" w="9525">
                   <a:solidFill>
                     <a:srgbClr val="000000"/>
                   </a:solidFill>
@@ -2506,7 +2506,7 @@
             </a:ln>
             <a:extLst>
               <a:ext uri="{91240B29-F687-4f45-9708-019B960494DF}">
-                <a14:hiddenLine xmlns="" xmlns:a14="http://schemas.microsoft.com/office/drawing/2010/main" w="9525">
+                <a14:hiddenLine xmlns:a14="http://schemas.microsoft.com/office/drawing/2010/main" xmlns="" w="9525">
                   <a:solidFill>
                     <a:srgbClr val="000000"/>
                   </a:solidFill>
@@ -2569,7 +2569,7 @@
             </a:ln>
             <a:extLst>
               <a:ext uri="{91240B29-F687-4f45-9708-019B960494DF}">
-                <a14:hiddenLine xmlns="" xmlns:a14="http://schemas.microsoft.com/office/drawing/2010/main" w="9525">
+                <a14:hiddenLine xmlns:a14="http://schemas.microsoft.com/office/drawing/2010/main" xmlns="" w="9525">
                   <a:solidFill>
                     <a:srgbClr val="000000"/>
                   </a:solidFill>
@@ -2666,7 +2666,7 @@
             </a:ln>
             <a:extLst>
               <a:ext uri="{91240B29-F687-4f45-9708-019B960494DF}">
-                <a14:hiddenLine xmlns="" xmlns:a14="http://schemas.microsoft.com/office/drawing/2010/main" w="9525">
+                <a14:hiddenLine xmlns:a14="http://schemas.microsoft.com/office/drawing/2010/main" xmlns="" w="9525">
                   <a:solidFill>
                     <a:srgbClr val="000000"/>
                   </a:solidFill>
@@ -2729,7 +2729,7 @@
             </a:ln>
             <a:extLst>
               <a:ext uri="{91240B29-F687-4f45-9708-019B960494DF}">
-                <a14:hiddenLine xmlns="" xmlns:a14="http://schemas.microsoft.com/office/drawing/2010/main" w="9525">
+                <a14:hiddenLine xmlns:a14="http://schemas.microsoft.com/office/drawing/2010/main" xmlns="" w="9525">
                   <a:solidFill>
                     <a:srgbClr val="000000"/>
                   </a:solidFill>
@@ -2826,7 +2826,7 @@
             </a:ln>
             <a:extLst>
               <a:ext uri="{91240B29-F687-4f45-9708-019B960494DF}">
-                <a14:hiddenLine xmlns="" xmlns:a14="http://schemas.microsoft.com/office/drawing/2010/main" w="9525">
+                <a14:hiddenLine xmlns:a14="http://schemas.microsoft.com/office/drawing/2010/main" xmlns="" w="9525">
                   <a:solidFill>
                     <a:srgbClr val="000000"/>
                   </a:solidFill>
@@ -2901,7 +2901,7 @@
             </a:ln>
             <a:extLst>
               <a:ext uri="{91240B29-F687-4f45-9708-019B960494DF}">
-                <a14:hiddenLine xmlns="" xmlns:a14="http://schemas.microsoft.com/office/drawing/2010/main" w="9525">
+                <a14:hiddenLine xmlns:a14="http://schemas.microsoft.com/office/drawing/2010/main" xmlns="" w="9525">
                   <a:solidFill>
                     <a:srgbClr val="000000"/>
                   </a:solidFill>
@@ -2998,7 +2998,7 @@
             </a:ln>
             <a:extLst>
               <a:ext uri="{91240B29-F687-4f45-9708-019B960494DF}">
-                <a14:hiddenLine xmlns="" xmlns:a14="http://schemas.microsoft.com/office/drawing/2010/main" w="9525">
+                <a14:hiddenLine xmlns:a14="http://schemas.microsoft.com/office/drawing/2010/main" xmlns="" w="9525">
                   <a:solidFill>
                     <a:srgbClr val="000000"/>
                   </a:solidFill>
@@ -3073,7 +3073,7 @@
             </a:ln>
             <a:extLst>
               <a:ext uri="{91240B29-F687-4f45-9708-019B960494DF}">
-                <a14:hiddenLine xmlns="" xmlns:a14="http://schemas.microsoft.com/office/drawing/2010/main" w="9525">
+                <a14:hiddenLine xmlns:a14="http://schemas.microsoft.com/office/drawing/2010/main" xmlns="" w="9525">
                   <a:solidFill>
                     <a:srgbClr val="000000"/>
                   </a:solidFill>
@@ -3170,7 +3170,7 @@
             </a:ln>
             <a:extLst>
               <a:ext uri="{91240B29-F687-4f45-9708-019B960494DF}">
-                <a14:hiddenLine xmlns="" xmlns:a14="http://schemas.microsoft.com/office/drawing/2010/main" w="9525">
+                <a14:hiddenLine xmlns:a14="http://schemas.microsoft.com/office/drawing/2010/main" xmlns="" w="9525">
                   <a:solidFill>
                     <a:srgbClr val="000000"/>
                   </a:solidFill>
@@ -3211,7 +3211,7 @@
             </a:ln>
             <a:extLst>
               <a:ext uri="{91240B29-F687-4f45-9708-019B960494DF}">
-                <a14:hiddenLine xmlns="" xmlns:a14="http://schemas.microsoft.com/office/drawing/2010/main" w="9525">
+                <a14:hiddenLine xmlns:a14="http://schemas.microsoft.com/office/drawing/2010/main" xmlns="" w="9525">
                   <a:solidFill>
                     <a:srgbClr val="000000"/>
                   </a:solidFill>
@@ -3308,7 +3308,7 @@
             </a:ln>
             <a:extLst>
               <a:ext uri="{91240B29-F687-4f45-9708-019B960494DF}">
-                <a14:hiddenLine xmlns="" xmlns:a14="http://schemas.microsoft.com/office/drawing/2010/main" w="9525">
+                <a14:hiddenLine xmlns:a14="http://schemas.microsoft.com/office/drawing/2010/main" xmlns="" w="9525">
                   <a:solidFill>
                     <a:srgbClr val="000000"/>
                   </a:solidFill>
@@ -3377,7 +3377,7 @@
             </a:ln>
             <a:extLst>
               <a:ext uri="{91240B29-F687-4f45-9708-019B960494DF}">
-                <a14:hiddenLine xmlns="" xmlns:a14="http://schemas.microsoft.com/office/drawing/2010/main" w="9525">
+                <a14:hiddenLine xmlns:a14="http://schemas.microsoft.com/office/drawing/2010/main" xmlns="" w="9525">
                   <a:solidFill>
                     <a:srgbClr val="000000"/>
                   </a:solidFill>
@@ -3446,7 +3446,7 @@
             </a:ln>
             <a:extLst>
               <a:ext uri="{91240B29-F687-4f45-9708-019B960494DF}">
-                <a14:hiddenLine xmlns="" xmlns:a14="http://schemas.microsoft.com/office/drawing/2010/main" w="9525">
+                <a14:hiddenLine xmlns:a14="http://schemas.microsoft.com/office/drawing/2010/main" xmlns="" w="9525">
                   <a:solidFill>
                     <a:srgbClr val="000000"/>
                   </a:solidFill>
@@ -3543,7 +3543,7 @@
             </a:ln>
             <a:extLst>
               <a:ext uri="{91240B29-F687-4f45-9708-019B960494DF}">
-                <a14:hiddenLine xmlns="" xmlns:a14="http://schemas.microsoft.com/office/drawing/2010/main" w="9525">
+                <a14:hiddenLine xmlns:a14="http://schemas.microsoft.com/office/drawing/2010/main" xmlns="" w="9525">
                   <a:solidFill>
                     <a:srgbClr val="000000"/>
                   </a:solidFill>
@@ -3618,7 +3618,7 @@
             </a:ln>
             <a:extLst>
               <a:ext uri="{91240B29-F687-4f45-9708-019B960494DF}">
-                <a14:hiddenLine xmlns="" xmlns:a14="http://schemas.microsoft.com/office/drawing/2010/main" w="9525">
+                <a14:hiddenLine xmlns:a14="http://schemas.microsoft.com/office/drawing/2010/main" xmlns="" w="9525">
                   <a:solidFill>
                     <a:srgbClr val="000000"/>
                   </a:solidFill>
@@ -3687,7 +3687,7 @@
             </a:ln>
             <a:extLst>
               <a:ext uri="{91240B29-F687-4f45-9708-019B960494DF}">
-                <a14:hiddenLine xmlns="" xmlns:a14="http://schemas.microsoft.com/office/drawing/2010/main" w="9525">
+                <a14:hiddenLine xmlns:a14="http://schemas.microsoft.com/office/drawing/2010/main" xmlns="" w="9525">
                   <a:solidFill>
                     <a:srgbClr val="000000"/>
                   </a:solidFill>
@@ -3784,7 +3784,7 @@
             </a:ln>
             <a:extLst>
               <a:ext uri="{91240B29-F687-4f45-9708-019B960494DF}">
-                <a14:hiddenLine xmlns="" xmlns:a14="http://schemas.microsoft.com/office/drawing/2010/main" w="9525">
+                <a14:hiddenLine xmlns:a14="http://schemas.microsoft.com/office/drawing/2010/main" xmlns="" w="9525">
                   <a:solidFill>
                     <a:srgbClr val="000000"/>
                   </a:solidFill>
@@ -3853,7 +3853,7 @@
             </a:ln>
             <a:extLst>
               <a:ext uri="{91240B29-F687-4f45-9708-019B960494DF}">
-                <a14:hiddenLine xmlns="" xmlns:a14="http://schemas.microsoft.com/office/drawing/2010/main" w="9525">
+                <a14:hiddenLine xmlns:a14="http://schemas.microsoft.com/office/drawing/2010/main" xmlns="" w="9525">
                   <a:solidFill>
                     <a:srgbClr val="000000"/>
                   </a:solidFill>
@@ -3950,7 +3950,7 @@
             </a:ln>
             <a:extLst>
               <a:ext uri="{91240B29-F687-4f45-9708-019B960494DF}">
-                <a14:hiddenLine xmlns="" xmlns:a14="http://schemas.microsoft.com/office/drawing/2010/main" w="9525">
+                <a14:hiddenLine xmlns:a14="http://schemas.microsoft.com/office/drawing/2010/main" xmlns="" w="9525">
                   <a:solidFill>
                     <a:srgbClr val="000000"/>
                   </a:solidFill>
@@ -4019,7 +4019,7 @@
             </a:ln>
             <a:extLst>
               <a:ext uri="{91240B29-F687-4f45-9708-019B960494DF}">
-                <a14:hiddenLine xmlns="" xmlns:a14="http://schemas.microsoft.com/office/drawing/2010/main" w="9525">
+                <a14:hiddenLine xmlns:a14="http://schemas.microsoft.com/office/drawing/2010/main" xmlns="" w="9525">
                   <a:solidFill>
                     <a:srgbClr val="000000"/>
                   </a:solidFill>
@@ -4116,7 +4116,7 @@
             </a:ln>
             <a:extLst>
               <a:ext uri="{91240B29-F687-4f45-9708-019B960494DF}">
-                <a14:hiddenLine xmlns="" xmlns:a14="http://schemas.microsoft.com/office/drawing/2010/main" w="9525">
+                <a14:hiddenLine xmlns:a14="http://schemas.microsoft.com/office/drawing/2010/main" xmlns="" w="9525">
                   <a:solidFill>
                     <a:srgbClr val="000000"/>
                   </a:solidFill>
@@ -4157,7 +4157,7 @@
             </a:ln>
             <a:extLst>
               <a:ext uri="{91240B29-F687-4f45-9708-019B960494DF}">
-                <a14:hiddenLine xmlns="" xmlns:a14="http://schemas.microsoft.com/office/drawing/2010/main" w="9525">
+                <a14:hiddenLine xmlns:a14="http://schemas.microsoft.com/office/drawing/2010/main" xmlns="" w="9525">
                   <a:solidFill>
                     <a:srgbClr val="000000"/>
                   </a:solidFill>
@@ -4229,7 +4229,7 @@
             </a:ln>
             <a:extLst>
               <a:ext uri="{91240B29-F687-4f45-9708-019B960494DF}">
-                <a14:hiddenLine xmlns="" xmlns:a14="http://schemas.microsoft.com/office/drawing/2010/main" w="9525">
+                <a14:hiddenLine xmlns:a14="http://schemas.microsoft.com/office/drawing/2010/main" xmlns="" w="9525">
                   <a:solidFill>
                     <a:srgbClr val="000000"/>
                   </a:solidFill>
@@ -4326,7 +4326,7 @@
             </a:ln>
             <a:extLst>
               <a:ext uri="{91240B29-F687-4f45-9708-019B960494DF}">
-                <a14:hiddenLine xmlns="" xmlns:a14="http://schemas.microsoft.com/office/drawing/2010/main" w="9525">
+                <a14:hiddenLine xmlns:a14="http://schemas.microsoft.com/office/drawing/2010/main" xmlns="" w="9525">
                   <a:solidFill>
                     <a:srgbClr val="000000"/>
                   </a:solidFill>
@@ -4395,7 +4395,7 @@
             </a:ln>
             <a:extLst>
               <a:ext uri="{91240B29-F687-4f45-9708-019B960494DF}">
-                <a14:hiddenLine xmlns="" xmlns:a14="http://schemas.microsoft.com/office/drawing/2010/main" w="9525">
+                <a14:hiddenLine xmlns:a14="http://schemas.microsoft.com/office/drawing/2010/main" xmlns="" w="9525">
                   <a:solidFill>
                     <a:srgbClr val="000000"/>
                   </a:solidFill>
@@ -4492,7 +4492,7 @@
             </a:ln>
             <a:extLst>
               <a:ext uri="{91240B29-F687-4f45-9708-019B960494DF}">
-                <a14:hiddenLine xmlns="" xmlns:a14="http://schemas.microsoft.com/office/drawing/2010/main" w="9525">
+                <a14:hiddenLine xmlns:a14="http://schemas.microsoft.com/office/drawing/2010/main" xmlns="" w="9525">
                   <a:solidFill>
                     <a:srgbClr val="000000"/>
                   </a:solidFill>
@@ -4589,7 +4589,7 @@
             </a:ln>
             <a:extLst>
               <a:ext uri="{91240B29-F687-4f45-9708-019B960494DF}">
-                <a14:hiddenLine xmlns="" xmlns:a14="http://schemas.microsoft.com/office/drawing/2010/main" w="9525">
+                <a14:hiddenLine xmlns:a14="http://schemas.microsoft.com/office/drawing/2010/main" xmlns="" w="9525">
                   <a:solidFill>
                     <a:srgbClr val="000000"/>
                   </a:solidFill>
@@ -4661,7 +4661,7 @@
             </a:ln>
             <a:extLst>
               <a:ext uri="{91240B29-F687-4f45-9708-019B960494DF}">
-                <a14:hiddenLine xmlns="" xmlns:a14="http://schemas.microsoft.com/office/drawing/2010/main" w="9525">
+                <a14:hiddenLine xmlns:a14="http://schemas.microsoft.com/office/drawing/2010/main" xmlns="" w="9525">
                   <a:solidFill>
                     <a:srgbClr val="000000"/>
                   </a:solidFill>
@@ -4730,7 +4730,7 @@
             </a:ln>
             <a:extLst>
               <a:ext uri="{91240B29-F687-4f45-9708-019B960494DF}">
-                <a14:hiddenLine xmlns="" xmlns:a14="http://schemas.microsoft.com/office/drawing/2010/main" w="9525">
+                <a14:hiddenLine xmlns:a14="http://schemas.microsoft.com/office/drawing/2010/main" xmlns="" w="9525">
                   <a:solidFill>
                     <a:srgbClr val="000000"/>
                   </a:solidFill>
@@ -4827,7 +4827,7 @@
             </a:ln>
             <a:extLst>
               <a:ext uri="{91240B29-F687-4f45-9708-019B960494DF}">
-                <a14:hiddenLine xmlns="" xmlns:a14="http://schemas.microsoft.com/office/drawing/2010/main" w="9525">
+                <a14:hiddenLine xmlns:a14="http://schemas.microsoft.com/office/drawing/2010/main" xmlns="" w="9525">
                   <a:solidFill>
                     <a:srgbClr val="000000"/>
                   </a:solidFill>
@@ -4924,7 +4924,7 @@
             </a:ln>
             <a:extLst>
               <a:ext uri="{91240B29-F687-4f45-9708-019B960494DF}">
-                <a14:hiddenLine xmlns="" xmlns:a14="http://schemas.microsoft.com/office/drawing/2010/main" w="9525">
+                <a14:hiddenLine xmlns:a14="http://schemas.microsoft.com/office/drawing/2010/main" xmlns="" w="9525">
                   <a:solidFill>
                     <a:srgbClr val="000000"/>
                   </a:solidFill>
@@ -4993,7 +4993,7 @@
             </a:ln>
             <a:extLst>
               <a:ext uri="{91240B29-F687-4f45-9708-019B960494DF}">
-                <a14:hiddenLine xmlns="" xmlns:a14="http://schemas.microsoft.com/office/drawing/2010/main" w="9525">
+                <a14:hiddenLine xmlns:a14="http://schemas.microsoft.com/office/drawing/2010/main" xmlns="" w="9525">
                   <a:solidFill>
                     <a:srgbClr val="000000"/>
                   </a:solidFill>
@@ -5120,7 +5120,7 @@
             </a:ln>
             <a:extLst>
               <a:ext uri="{91240B29-F687-4f45-9708-019B960494DF}">
-                <a14:hiddenLine xmlns="" xmlns:a14="http://schemas.microsoft.com/office/drawing/2010/main" w="9525">
+                <a14:hiddenLine xmlns:a14="http://schemas.microsoft.com/office/drawing/2010/main" xmlns="" w="9525">
                   <a:solidFill>
                     <a:srgbClr val="000000"/>
                   </a:solidFill>
@@ -5195,7 +5195,7 @@
             </a:ln>
             <a:extLst>
               <a:ext uri="{91240B29-F687-4f45-9708-019B960494DF}">
-                <a14:hiddenLine xmlns="" xmlns:a14="http://schemas.microsoft.com/office/drawing/2010/main" w="9525">
+                <a14:hiddenLine xmlns:a14="http://schemas.microsoft.com/office/drawing/2010/main" xmlns="" w="9525">
                   <a:solidFill>
                     <a:srgbClr val="000000"/>
                   </a:solidFill>
@@ -5292,7 +5292,7 @@
             </a:ln>
             <a:extLst>
               <a:ext uri="{91240B29-F687-4f45-9708-019B960494DF}">
-                <a14:hiddenLine xmlns="" xmlns:a14="http://schemas.microsoft.com/office/drawing/2010/main" w="9525">
+                <a14:hiddenLine xmlns:a14="http://schemas.microsoft.com/office/drawing/2010/main" xmlns="" w="9525">
                   <a:solidFill>
                     <a:srgbClr val="000000"/>
                   </a:solidFill>
@@ -5439,7 +5439,7 @@
           <a:p>
             <a:fld id="{48A87A34-81AB-432B-8DAE-1953F412C126}" type="datetimeFigureOut">
               <a:rPr lang="en-US" smtClean="0"/>
-              <a:t>9/24/2026</a:t>
+              <a:t>9/30/2026</a:t>
             </a:fld>
             <a:endParaRPr lang="en-US" dirty="0"/>
           </a:p>
@@ -5706,7 +5706,7 @@
           <a:p>
             <a:fld id="{48A87A34-81AB-432B-8DAE-1953F412C126}" type="datetimeFigureOut">
               <a:rPr lang="en-US" smtClean="0"/>
-              <a:t>9/24/2026</a:t>
+              <a:t>9/30/2026</a:t>
             </a:fld>
             <a:endParaRPr lang="en-US" dirty="0"/>
           </a:p>
@@ -5902,7 +5902,7 @@
           <a:p>
             <a:fld id="{48A87A34-81AB-432B-8DAE-1953F412C126}" type="datetimeFigureOut">
               <a:rPr lang="en-US" smtClean="0"/>
-              <a:t>9/24/2026</a:t>
+              <a:t>9/30/2026</a:t>
             </a:fld>
             <a:endParaRPr lang="en-US" dirty="0"/>
           </a:p>
@@ -6165,7 +6165,7 @@
           <a:p>
             <a:fld id="{48A87A34-81AB-432B-8DAE-1953F412C126}" type="datetimeFigureOut">
               <a:rPr lang="en-US" smtClean="0"/>
-              <a:t>9/24/2026</a:t>
+              <a:t>9/30/2026</a:t>
             </a:fld>
             <a:endParaRPr lang="en-US" dirty="0"/>
           </a:p>
@@ -6599,7 +6599,7 @@
           <a:p>
             <a:fld id="{48A87A34-81AB-432B-8DAE-1953F412C126}" type="datetimeFigureOut">
               <a:rPr lang="en-US" smtClean="0"/>
-              <a:t>9/24/2026</a:t>
+              <a:t>9/30/2026</a:t>
             </a:fld>
             <a:endParaRPr lang="en-US" dirty="0"/>
           </a:p>
@@ -7145,7 +7145,7 @@
           <a:p>
             <a:fld id="{48A87A34-81AB-432B-8DAE-1953F412C126}" type="datetimeFigureOut">
               <a:rPr lang="en-US" smtClean="0"/>
-              <a:t>9/24/2026</a:t>
+              <a:t>9/30/2026</a:t>
             </a:fld>
             <a:endParaRPr lang="en-US" dirty="0"/>
           </a:p>
@@ -7865,7 +7865,7 @@
           <a:p>
             <a:fld id="{48A87A34-81AB-432B-8DAE-1953F412C126}" type="datetimeFigureOut">
               <a:rPr lang="en-US" smtClean="0"/>
-              <a:t>9/24/2026</a:t>
+              <a:t>9/30/2026</a:t>
             </a:fld>
             <a:endParaRPr lang="en-US" dirty="0"/>
           </a:p>
@@ -8035,7 +8035,7 @@
           <a:p>
             <a:fld id="{48A87A34-81AB-432B-8DAE-1953F412C126}" type="datetimeFigureOut">
               <a:rPr lang="en-US" smtClean="0"/>
-              <a:t>9/24/2026</a:t>
+              <a:t>9/30/2026</a:t>
             </a:fld>
             <a:endParaRPr lang="en-US" dirty="0"/>
           </a:p>
@@ -8215,7 +8215,7 @@
           <a:p>
             <a:fld id="{48A87A34-81AB-432B-8DAE-1953F412C126}" type="datetimeFigureOut">
               <a:rPr lang="en-US" smtClean="0"/>
-              <a:t>9/24/2026</a:t>
+              <a:t>9/30/2026</a:t>
             </a:fld>
             <a:endParaRPr lang="en-US" dirty="0"/>
           </a:p>
@@ -8385,7 +8385,7 @@
           <a:p>
             <a:fld id="{48A87A34-81AB-432B-8DAE-1953F412C126}" type="datetimeFigureOut">
               <a:rPr lang="en-US" smtClean="0"/>
-              <a:t>9/24/2026</a:t>
+              <a:t>9/30/2026</a:t>
             </a:fld>
             <a:endParaRPr lang="en-US" dirty="0"/>
           </a:p>
@@ -8635,7 +8635,7 @@
           <a:p>
             <a:fld id="{48A87A34-81AB-432B-8DAE-1953F412C126}" type="datetimeFigureOut">
               <a:rPr lang="en-US" smtClean="0"/>
-              <a:t>9/24/2026</a:t>
+              <a:t>9/30/2026</a:t>
             </a:fld>
             <a:endParaRPr lang="en-US" dirty="0"/>
           </a:p>
@@ -8867,7 +8867,7 @@
           <a:p>
             <a:fld id="{48A87A34-81AB-432B-8DAE-1953F412C126}" type="datetimeFigureOut">
               <a:rPr lang="en-US" smtClean="0"/>
-              <a:t>9/24/2026</a:t>
+              <a:t>9/30/2026</a:t>
             </a:fld>
             <a:endParaRPr lang="en-US" dirty="0"/>
           </a:p>
@@ -9248,7 +9248,7 @@
           <a:p>
             <a:fld id="{48A87A34-81AB-432B-8DAE-1953F412C126}" type="datetimeFigureOut">
               <a:rPr lang="en-US" smtClean="0"/>
-              <a:t>9/24/2026</a:t>
+              <a:t>9/30/2026</a:t>
             </a:fld>
             <a:endParaRPr lang="en-US" dirty="0"/>
           </a:p>
@@ -9366,7 +9366,7 @@
           <a:p>
             <a:fld id="{48A87A34-81AB-432B-8DAE-1953F412C126}" type="datetimeFigureOut">
               <a:rPr lang="en-US" smtClean="0"/>
-              <a:t>9/24/2026</a:t>
+              <a:t>9/30/2026</a:t>
             </a:fld>
             <a:endParaRPr lang="en-US" dirty="0"/>
           </a:p>
@@ -9461,7 +9461,7 @@
           <a:p>
             <a:fld id="{48A87A34-81AB-432B-8DAE-1953F412C126}" type="datetimeFigureOut">
               <a:rPr lang="en-US" smtClean="0"/>
-              <a:t>9/24/2026</a:t>
+              <a:t>9/30/2026</a:t>
             </a:fld>
             <a:endParaRPr lang="en-US" dirty="0"/>
           </a:p>
@@ -9710,7 +9710,7 @@
           <a:p>
             <a:fld id="{48A87A34-81AB-432B-8DAE-1953F412C126}" type="datetimeFigureOut">
               <a:rPr lang="en-US" smtClean="0"/>
-              <a:t>9/24/2026</a:t>
+              <a:t>9/30/2026</a:t>
             </a:fld>
             <a:endParaRPr lang="en-US" dirty="0"/>
           </a:p>
@@ -9990,7 +9990,7 @@
           <a:p>
             <a:fld id="{48A87A34-81AB-432B-8DAE-1953F412C126}" type="datetimeFigureOut">
               <a:rPr lang="en-US" smtClean="0"/>
-              <a:t>9/24/2026</a:t>
+              <a:t>9/30/2026</a:t>
             </a:fld>
             <a:endParaRPr lang="en-US" dirty="0"/>
           </a:p>
@@ -10113,7 +10113,7 @@
           <a:noFill/>
           <a:extLst>
             <a:ext uri="{909E8E84-426E-40dd-AFC4-6F175D3DCCD1}">
-              <a14:hiddenFill xmlns="" xmlns:a14="http://schemas.microsoft.com/office/drawing/2010/main">
+              <a14:hiddenFill xmlns:a14="http://schemas.microsoft.com/office/drawing/2010/main" xmlns="">
                 <a:solidFill>
                   <a:srgbClr val="FFFFFF"/>
                 </a:solidFill>
@@ -10187,7 +10187,7 @@
               </a:ln>
               <a:extLst>
                 <a:ext uri="{91240B29-F687-4f45-9708-019B960494DF}">
-                  <a14:hiddenLine xmlns="" xmlns:a14="http://schemas.microsoft.com/office/drawing/2010/main" w="9525">
+                  <a14:hiddenLine xmlns:a14="http://schemas.microsoft.com/office/drawing/2010/main" xmlns="" w="9525">
                     <a:solidFill>
                       <a:srgbClr val="000000"/>
                     </a:solidFill>
@@ -10284,7 +10284,7 @@
               </a:ln>
               <a:extLst>
                 <a:ext uri="{91240B29-F687-4f45-9708-019B960494DF}">
-                  <a14:hiddenLine xmlns="" xmlns:a14="http://schemas.microsoft.com/office/drawing/2010/main" w="9525">
+                  <a14:hiddenLine xmlns:a14="http://schemas.microsoft.com/office/drawing/2010/main" xmlns="" w="9525">
                     <a:solidFill>
                       <a:srgbClr val="000000"/>
                     </a:solidFill>
@@ -10381,7 +10381,7 @@
               </a:ln>
               <a:extLst>
                 <a:ext uri="{91240B29-F687-4f45-9708-019B960494DF}">
-                  <a14:hiddenLine xmlns="" xmlns:a14="http://schemas.microsoft.com/office/drawing/2010/main" w="9525">
+                  <a14:hiddenLine xmlns:a14="http://schemas.microsoft.com/office/drawing/2010/main" xmlns="" w="9525">
                     <a:solidFill>
                       <a:srgbClr val="000000"/>
                     </a:solidFill>
@@ -10450,7 +10450,7 @@
               </a:ln>
               <a:extLst>
                 <a:ext uri="{91240B29-F687-4f45-9708-019B960494DF}">
-                  <a14:hiddenLine xmlns="" xmlns:a14="http://schemas.microsoft.com/office/drawing/2010/main" w="9525">
+                  <a14:hiddenLine xmlns:a14="http://schemas.microsoft.com/office/drawing/2010/main" xmlns="" w="9525">
                     <a:solidFill>
                       <a:srgbClr val="000000"/>
                     </a:solidFill>
@@ -10547,7 +10547,7 @@
               </a:ln>
               <a:extLst>
                 <a:ext uri="{91240B29-F687-4f45-9708-019B960494DF}">
-                  <a14:hiddenLine xmlns="" xmlns:a14="http://schemas.microsoft.com/office/drawing/2010/main" w="9525">
+                  <a14:hiddenLine xmlns:a14="http://schemas.microsoft.com/office/drawing/2010/main" xmlns="" w="9525">
                     <a:solidFill>
                       <a:srgbClr val="000000"/>
                     </a:solidFill>
@@ -10616,7 +10616,7 @@
               </a:ln>
               <a:extLst>
                 <a:ext uri="{91240B29-F687-4f45-9708-019B960494DF}">
-                  <a14:hiddenLine xmlns="" xmlns:a14="http://schemas.microsoft.com/office/drawing/2010/main" w="9525">
+                  <a14:hiddenLine xmlns:a14="http://schemas.microsoft.com/office/drawing/2010/main" xmlns="" w="9525">
                     <a:solidFill>
                       <a:srgbClr val="000000"/>
                     </a:solidFill>
@@ -10685,7 +10685,7 @@
               </a:ln>
               <a:extLst>
                 <a:ext uri="{91240B29-F687-4f45-9708-019B960494DF}">
-                  <a14:hiddenLine xmlns="" xmlns:a14="http://schemas.microsoft.com/office/drawing/2010/main" w="9525">
+                  <a14:hiddenLine xmlns:a14="http://schemas.microsoft.com/office/drawing/2010/main" xmlns="" w="9525">
                     <a:solidFill>
                       <a:srgbClr val="000000"/>
                     </a:solidFill>
@@ -10782,7 +10782,7 @@
               </a:ln>
               <a:extLst>
                 <a:ext uri="{91240B29-F687-4f45-9708-019B960494DF}">
-                  <a14:hiddenLine xmlns="" xmlns:a14="http://schemas.microsoft.com/office/drawing/2010/main" w="9525">
+                  <a14:hiddenLine xmlns:a14="http://schemas.microsoft.com/office/drawing/2010/main" xmlns="" w="9525">
                     <a:solidFill>
                       <a:srgbClr val="000000"/>
                     </a:solidFill>
@@ -10879,7 +10879,7 @@
               </a:ln>
               <a:extLst>
                 <a:ext uri="{91240B29-F687-4f45-9708-019B960494DF}">
-                  <a14:hiddenLine xmlns="" xmlns:a14="http://schemas.microsoft.com/office/drawing/2010/main" w="9525">
+                  <a14:hiddenLine xmlns:a14="http://schemas.microsoft.com/office/drawing/2010/main" xmlns="" w="9525">
                     <a:solidFill>
                       <a:srgbClr val="000000"/>
                     </a:solidFill>
@@ -10948,7 +10948,7 @@
               </a:ln>
               <a:extLst>
                 <a:ext uri="{91240B29-F687-4f45-9708-019B960494DF}">
-                  <a14:hiddenLine xmlns="" xmlns:a14="http://schemas.microsoft.com/office/drawing/2010/main" w="9525">
+                  <a14:hiddenLine xmlns:a14="http://schemas.microsoft.com/office/drawing/2010/main" xmlns="" w="9525">
                     <a:solidFill>
                       <a:srgbClr val="000000"/>
                     </a:solidFill>
@@ -11065,7 +11065,7 @@
               </a:ln>
               <a:extLst>
                 <a:ext uri="{91240B29-F687-4f45-9708-019B960494DF}">
-                  <a14:hiddenLine xmlns="" xmlns:a14="http://schemas.microsoft.com/office/drawing/2010/main" w="9525">
+                  <a14:hiddenLine xmlns:a14="http://schemas.microsoft.com/office/drawing/2010/main" xmlns="" w="9525">
                     <a:solidFill>
                       <a:srgbClr val="000000"/>
                     </a:solidFill>
@@ -11163,7 +11163,7 @@
               </a:ln>
               <a:extLst>
                 <a:ext uri="{91240B29-F687-4f45-9708-019B960494DF}">
-                  <a14:hiddenLine xmlns="" xmlns:a14="http://schemas.microsoft.com/office/drawing/2010/main" w="9525">
+                  <a14:hiddenLine xmlns:a14="http://schemas.microsoft.com/office/drawing/2010/main" xmlns="" w="9525">
                     <a:solidFill>
                       <a:srgbClr val="000000"/>
                     </a:solidFill>
@@ -11232,7 +11232,7 @@
               </a:ln>
               <a:extLst>
                 <a:ext uri="{91240B29-F687-4f45-9708-019B960494DF}">
-                  <a14:hiddenLine xmlns="" xmlns:a14="http://schemas.microsoft.com/office/drawing/2010/main" w="9525">
+                  <a14:hiddenLine xmlns:a14="http://schemas.microsoft.com/office/drawing/2010/main" xmlns="" w="9525">
                     <a:solidFill>
                       <a:srgbClr val="000000"/>
                     </a:solidFill>
@@ -11301,7 +11301,7 @@
               </a:ln>
               <a:extLst>
                 <a:ext uri="{91240B29-F687-4f45-9708-019B960494DF}">
-                  <a14:hiddenLine xmlns="" xmlns:a14="http://schemas.microsoft.com/office/drawing/2010/main" w="9525">
+                  <a14:hiddenLine xmlns:a14="http://schemas.microsoft.com/office/drawing/2010/main" xmlns="" w="9525">
                     <a:solidFill>
                       <a:srgbClr val="000000"/>
                     </a:solidFill>
@@ -11398,7 +11398,7 @@
               </a:ln>
               <a:extLst>
                 <a:ext uri="{91240B29-F687-4f45-9708-019B960494DF}">
-                  <a14:hiddenLine xmlns="" xmlns:a14="http://schemas.microsoft.com/office/drawing/2010/main" w="9525">
+                  <a14:hiddenLine xmlns:a14="http://schemas.microsoft.com/office/drawing/2010/main" xmlns="" w="9525">
                     <a:solidFill>
                       <a:srgbClr val="000000"/>
                     </a:solidFill>
@@ -11439,7 +11439,7 @@
               </a:ln>
               <a:extLst>
                 <a:ext uri="{91240B29-F687-4f45-9708-019B960494DF}">
-                  <a14:hiddenLine xmlns="" xmlns:a14="http://schemas.microsoft.com/office/drawing/2010/main" w="9525">
+                  <a14:hiddenLine xmlns:a14="http://schemas.microsoft.com/office/drawing/2010/main" xmlns="" w="9525">
                     <a:solidFill>
                       <a:srgbClr val="000000"/>
                     </a:solidFill>
@@ -11511,7 +11511,7 @@
               </a:ln>
               <a:extLst>
                 <a:ext uri="{91240B29-F687-4f45-9708-019B960494DF}">
-                  <a14:hiddenLine xmlns="" xmlns:a14="http://schemas.microsoft.com/office/drawing/2010/main" w="9525">
+                  <a14:hiddenLine xmlns:a14="http://schemas.microsoft.com/office/drawing/2010/main" xmlns="" w="9525">
                     <a:solidFill>
                       <a:srgbClr val="000000"/>
                     </a:solidFill>
@@ -11608,7 +11608,7 @@
               </a:ln>
               <a:extLst>
                 <a:ext uri="{91240B29-F687-4f45-9708-019B960494DF}">
-                  <a14:hiddenLine xmlns="" xmlns:a14="http://schemas.microsoft.com/office/drawing/2010/main" w="9525">
+                  <a14:hiddenLine xmlns:a14="http://schemas.microsoft.com/office/drawing/2010/main" xmlns="" w="9525">
                     <a:solidFill>
                       <a:srgbClr val="000000"/>
                     </a:solidFill>
@@ -11677,7 +11677,7 @@
               </a:ln>
               <a:extLst>
                 <a:ext uri="{91240B29-F687-4f45-9708-019B960494DF}">
-                  <a14:hiddenLine xmlns="" xmlns:a14="http://schemas.microsoft.com/office/drawing/2010/main" w="9525">
+                  <a14:hiddenLine xmlns:a14="http://schemas.microsoft.com/office/drawing/2010/main" xmlns="" w="9525">
                     <a:solidFill>
                       <a:srgbClr val="000000"/>
                     </a:solidFill>
@@ -11774,7 +11774,7 @@
               </a:ln>
               <a:extLst>
                 <a:ext uri="{91240B29-F687-4f45-9708-019B960494DF}">
-                  <a14:hiddenLine xmlns="" xmlns:a14="http://schemas.microsoft.com/office/drawing/2010/main" w="9525">
+                  <a14:hiddenLine xmlns:a14="http://schemas.microsoft.com/office/drawing/2010/main" xmlns="" w="9525">
                     <a:solidFill>
                       <a:srgbClr val="000000"/>
                     </a:solidFill>
@@ -11846,7 +11846,7 @@
               </a:ln>
               <a:extLst>
                 <a:ext uri="{91240B29-F687-4f45-9708-019B960494DF}">
-                  <a14:hiddenLine xmlns="" xmlns:a14="http://schemas.microsoft.com/office/drawing/2010/main" w="9525">
+                  <a14:hiddenLine xmlns:a14="http://schemas.microsoft.com/office/drawing/2010/main" xmlns="" w="9525">
                     <a:solidFill>
                       <a:srgbClr val="000000"/>
                     </a:solidFill>
@@ -11915,7 +11915,7 @@
               </a:ln>
               <a:extLst>
                 <a:ext uri="{91240B29-F687-4f45-9708-019B960494DF}">
-                  <a14:hiddenLine xmlns="" xmlns:a14="http://schemas.microsoft.com/office/drawing/2010/main" w="9525">
+                  <a14:hiddenLine xmlns:a14="http://schemas.microsoft.com/office/drawing/2010/main" xmlns="" w="9525">
                     <a:solidFill>
                       <a:srgbClr val="000000"/>
                     </a:solidFill>
@@ -12012,7 +12012,7 @@
               </a:ln>
               <a:extLst>
                 <a:ext uri="{91240B29-F687-4f45-9708-019B960494DF}">
-                  <a14:hiddenLine xmlns="" xmlns:a14="http://schemas.microsoft.com/office/drawing/2010/main" w="9525">
+                  <a14:hiddenLine xmlns:a14="http://schemas.microsoft.com/office/drawing/2010/main" xmlns="" w="9525">
                     <a:solidFill>
                       <a:srgbClr val="000000"/>
                     </a:solidFill>
@@ -12109,7 +12109,7 @@
               </a:ln>
               <a:extLst>
                 <a:ext uri="{91240B29-F687-4f45-9708-019B960494DF}">
-                  <a14:hiddenLine xmlns="" xmlns:a14="http://schemas.microsoft.com/office/drawing/2010/main" w="9525">
+                  <a14:hiddenLine xmlns:a14="http://schemas.microsoft.com/office/drawing/2010/main" xmlns="" w="9525">
                     <a:solidFill>
                       <a:srgbClr val="000000"/>
                     </a:solidFill>
@@ -12181,7 +12181,7 @@
               </a:ln>
               <a:extLst>
                 <a:ext uri="{91240B29-F687-4f45-9708-019B960494DF}">
-                  <a14:hiddenLine xmlns="" xmlns:a14="http://schemas.microsoft.com/office/drawing/2010/main" w="9525">
+                  <a14:hiddenLine xmlns:a14="http://schemas.microsoft.com/office/drawing/2010/main" xmlns="" w="9525">
                     <a:solidFill>
                       <a:srgbClr val="000000"/>
                     </a:solidFill>
@@ -12308,7 +12308,7 @@
               </a:ln>
               <a:extLst>
                 <a:ext uri="{91240B29-F687-4f45-9708-019B960494DF}">
-                  <a14:hiddenLine xmlns="" xmlns:a14="http://schemas.microsoft.com/office/drawing/2010/main" w="9525">
+                  <a14:hiddenLine xmlns:a14="http://schemas.microsoft.com/office/drawing/2010/main" xmlns="" w="9525">
                     <a:solidFill>
                       <a:srgbClr val="000000"/>
                     </a:solidFill>
@@ -12396,7 +12396,7 @@
               </a:ln>
               <a:extLst>
                 <a:ext uri="{91240B29-F687-4f45-9708-019B960494DF}">
-                  <a14:hiddenLine xmlns="" xmlns:a14="http://schemas.microsoft.com/office/drawing/2010/main" w="9525">
+                  <a14:hiddenLine xmlns:a14="http://schemas.microsoft.com/office/drawing/2010/main" xmlns="" w="9525">
                     <a:solidFill>
                       <a:srgbClr val="000000"/>
                     </a:solidFill>
@@ -12518,7 +12518,7 @@
               </a:ln>
               <a:extLst>
                 <a:ext uri="{91240B29-F687-4f45-9708-019B960494DF}">
-                  <a14:hiddenLine xmlns="" xmlns:a14="http://schemas.microsoft.com/office/drawing/2010/main" w="9525">
+                  <a14:hiddenLine xmlns:a14="http://schemas.microsoft.com/office/drawing/2010/main" xmlns="" w="9525">
                     <a:solidFill>
                       <a:srgbClr val="000000"/>
                     </a:solidFill>
@@ -12615,7 +12615,7 @@
               </a:ln>
               <a:extLst>
                 <a:ext uri="{91240B29-F687-4f45-9708-019B960494DF}">
-                  <a14:hiddenLine xmlns="" xmlns:a14="http://schemas.microsoft.com/office/drawing/2010/main" w="9525">
+                  <a14:hiddenLine xmlns:a14="http://schemas.microsoft.com/office/drawing/2010/main" xmlns="" w="9525">
                     <a:solidFill>
                       <a:srgbClr val="000000"/>
                     </a:solidFill>
@@ -12687,7 +12687,7 @@
               </a:ln>
               <a:extLst>
                 <a:ext uri="{91240B29-F687-4f45-9708-019B960494DF}">
-                  <a14:hiddenLine xmlns="" xmlns:a14="http://schemas.microsoft.com/office/drawing/2010/main" w="9525">
+                  <a14:hiddenLine xmlns:a14="http://schemas.microsoft.com/office/drawing/2010/main" xmlns="" w="9525">
                     <a:solidFill>
                       <a:srgbClr val="000000"/>
                     </a:solidFill>
@@ -12784,7 +12784,7 @@
               </a:ln>
               <a:extLst>
                 <a:ext uri="{91240B29-F687-4f45-9708-019B960494DF}">
-                  <a14:hiddenLine xmlns="" xmlns:a14="http://schemas.microsoft.com/office/drawing/2010/main" w="9525">
+                  <a14:hiddenLine xmlns:a14="http://schemas.microsoft.com/office/drawing/2010/main" xmlns="" w="9525">
                     <a:solidFill>
                       <a:srgbClr val="000000"/>
                     </a:solidFill>
@@ -12859,7 +12859,7 @@
               </a:ln>
               <a:extLst>
                 <a:ext uri="{91240B29-F687-4f45-9708-019B960494DF}">
-                  <a14:hiddenLine xmlns="" xmlns:a14="http://schemas.microsoft.com/office/drawing/2010/main" w="9525">
+                  <a14:hiddenLine xmlns:a14="http://schemas.microsoft.com/office/drawing/2010/main" xmlns="" w="9525">
                     <a:solidFill>
                       <a:srgbClr val="000000"/>
                     </a:solidFill>
@@ -12956,7 +12956,7 @@
               </a:ln>
               <a:extLst>
                 <a:ext uri="{91240B29-F687-4f45-9708-019B960494DF}">
-                  <a14:hiddenLine xmlns="" xmlns:a14="http://schemas.microsoft.com/office/drawing/2010/main" w="9525">
+                  <a14:hiddenLine xmlns:a14="http://schemas.microsoft.com/office/drawing/2010/main" xmlns="" w="9525">
                     <a:solidFill>
                       <a:srgbClr val="000000"/>
                     </a:solidFill>
@@ -13031,7 +13031,7 @@
               </a:ln>
               <a:extLst>
                 <a:ext uri="{91240B29-F687-4f45-9708-019B960494DF}">
-                  <a14:hiddenLine xmlns="" xmlns:a14="http://schemas.microsoft.com/office/drawing/2010/main" w="9525">
+                  <a14:hiddenLine xmlns:a14="http://schemas.microsoft.com/office/drawing/2010/main" xmlns="" w="9525">
                     <a:solidFill>
                       <a:srgbClr val="000000"/>
                     </a:solidFill>
@@ -13128,7 +13128,7 @@
               </a:ln>
               <a:extLst>
                 <a:ext uri="{91240B29-F687-4f45-9708-019B960494DF}">
-                  <a14:hiddenLine xmlns="" xmlns:a14="http://schemas.microsoft.com/office/drawing/2010/main" w="9525">
+                  <a14:hiddenLine xmlns:a14="http://schemas.microsoft.com/office/drawing/2010/main" xmlns="" w="9525">
                     <a:solidFill>
                       <a:srgbClr val="000000"/>
                     </a:solidFill>
@@ -13169,7 +13169,7 @@
               </a:ln>
               <a:extLst>
                 <a:ext uri="{91240B29-F687-4f45-9708-019B960494DF}">
-                  <a14:hiddenLine xmlns="" xmlns:a14="http://schemas.microsoft.com/office/drawing/2010/main" w="9525">
+                  <a14:hiddenLine xmlns:a14="http://schemas.microsoft.com/office/drawing/2010/main" xmlns="" w="9525">
                     <a:solidFill>
                       <a:srgbClr val="000000"/>
                     </a:solidFill>
@@ -13317,7 +13317,7 @@
             <a:fld id="{48A87A34-81AB-432B-8DAE-1953F412C126}" type="datetimeFigureOut">
               <a:rPr lang="en-US" smtClean="0"/>
               <a:pPr/>
-              <a:t>9/24/2026</a:t>
+              <a:t>9/30/2026</a:t>
             </a:fld>
             <a:endParaRPr lang="en-US" dirty="0"/>
           </a:p>
@@ -16755,9 +16755,16 @@
             <p:ph type="title"/>
           </p:nvPr>
         </p:nvSpPr>
-        <p:spPr/>
+        <p:spPr>
+          <a:xfrm>
+            <a:off x="1141413" y="618518"/>
+            <a:ext cx="9905998" cy="1478570"/>
+          </a:xfrm>
+        </p:spPr>
         <p:txBody>
-          <a:bodyPr/>
+          <a:bodyPr anchor="ctr">
+            <a:normAutofit/>
+          </a:bodyPr>
           <a:lstStyle/>
           <a:p>
             <a:r>
@@ -16784,9 +16791,16 @@
             <p:ph sz="half" idx="1"/>
           </p:nvPr>
         </p:nvSpPr>
-        <p:spPr/>
+        <p:spPr>
+          <a:xfrm>
+            <a:off x="1141410" y="2249486"/>
+            <a:ext cx="4878389" cy="3541714"/>
+          </a:xfrm>
+        </p:spPr>
         <p:txBody>
-          <a:bodyPr/>
+          <a:bodyPr>
+            <a:normAutofit/>
+          </a:bodyPr>
           <a:lstStyle/>
           <a:p>
             <a:r>
@@ -16802,31 +16816,40 @@
           </a:p>
         </p:txBody>
       </p:sp>
-      <p:sp>
-        <p:nvSpPr>
-          <p:cNvPr id="4" name="Content Placeholder 3">
+      <p:pic>
+        <p:nvPicPr>
+          <p:cNvPr id="6" name="Content Placeholder 5">
             <a:extLst>
               <a:ext uri="{FF2B5EF4-FFF2-40B4-BE49-F238E27FC236}">
-                <a16:creationId xmlns:a16="http://schemas.microsoft.com/office/drawing/2014/main" id="{ADD7FC26-DFE6-FA59-4030-754EE42D7D74}"/>
+                <a16:creationId xmlns:a16="http://schemas.microsoft.com/office/drawing/2014/main" id="{FDD98EAF-CEFD-D50F-3890-82C2AAC4DAA7}"/>
               </a:ext>
             </a:extLst>
           </p:cNvPr>
-          <p:cNvSpPr>
-            <a:spLocks noGrp="1"/>
-          </p:cNvSpPr>
+          <p:cNvPicPr>
+            <a:picLocks noGrp="1" noChangeAspect="1"/>
+          </p:cNvPicPr>
           <p:nvPr>
             <p:ph sz="half" idx="2"/>
           </p:nvPr>
-        </p:nvSpPr>
-        <p:spPr/>
-        <p:txBody>
-          <a:bodyPr/>
-          <a:lstStyle/>
-          <a:p>
-            <a:endParaRPr lang="en-US"/>
-          </a:p>
-        </p:txBody>
-      </p:sp>
+        </p:nvPicPr>
+        <p:blipFill>
+          <a:blip r:embed="rId2"/>
+          <a:srcRect l="5317" r="20695" b="-1"/>
+          <a:stretch>
+            <a:fillRect/>
+          </a:stretch>
+        </p:blipFill>
+        <p:spPr>
+          <a:xfrm>
+            <a:off x="6172200" y="2249486"/>
+            <a:ext cx="4875211" cy="3541714"/>
+          </a:xfrm>
+          <a:prstGeom prst="rect">
+            <a:avLst/>
+          </a:prstGeom>
+          <a:noFill/>
+        </p:spPr>
+      </p:pic>
     </p:spTree>
     <p:extLst>
       <p:ext uri="{BB962C8B-B14F-4D97-AF65-F5344CB8AC3E}">
@@ -17682,15 +17705,6 @@
 </file>
 
 <file path=customXml/item1.xml><?xml version="1.0" encoding="utf-8"?>
-<?mso-contentType ?>
-<FormTemplates xmlns="http://schemas.microsoft.com/sharepoint/v3/contenttype/forms">
-  <Display>DocumentLibraryForm</Display>
-  <Edit>DocumentLibraryForm</Edit>
-  <New>DocumentLibraryForm</New>
-</FormTemplates>
-</file>
-
-<file path=customXml/item2.xml><?xml version="1.0" encoding="utf-8"?>
 <ct:contentTypeSchema xmlns:ct="http://schemas.microsoft.com/office/2006/metadata/contentType" xmlns:ma="http://schemas.microsoft.com/office/2006/metadata/properties/metaAttributes" ct:_="" ma:_="" ma:contentTypeName="Document" ma:contentTypeID="0x01010079F111ED35F8CC479449609E8A0923A6" ma:contentTypeVersion="11" ma:contentTypeDescription="Create a new document." ma:contentTypeScope="" ma:versionID="96291512c1ee715ab617f4c07df79fc1">
   <xsd:schema xmlns:xsd="http://www.w3.org/2001/XMLSchema" xmlns:xs="http://www.w3.org/2001/XMLSchema" xmlns:p="http://schemas.microsoft.com/office/2006/metadata/properties" xmlns:ns2="71af3243-3dd4-4a8d-8c0d-dd76da1f02a5" xmlns:ns3="16c05727-aa75-4e4a-9b5f-8a80a1165891" targetNamespace="http://schemas.microsoft.com/office/2006/metadata/properties" ma:root="true" ma:fieldsID="8256c27c40ca5c40ce1cf6c44f0205df" ns2:_="" ns3:_="">
     <xsd:import namespace="71af3243-3dd4-4a8d-8c0d-dd76da1f02a5"/>
@@ -17901,6 +17915,15 @@
 </ct:contentTypeSchema>
 </file>
 
+<file path=customXml/item2.xml><?xml version="1.0" encoding="utf-8"?>
+<?mso-contentType ?>
+<FormTemplates xmlns="http://schemas.microsoft.com/sharepoint/v3/contenttype/forms">
+  <Display>DocumentLibraryForm</Display>
+  <Edit>DocumentLibraryForm</Edit>
+  <New>DocumentLibraryForm</New>
+</FormTemplates>
+</file>
+
 <file path=customXml/item3.xml><?xml version="1.0" encoding="utf-8"?>
 <p:properties xmlns:p="http://schemas.microsoft.com/office/2006/metadata/properties" xmlns:xsi="http://www.w3.org/2001/XMLSchema-instance" xmlns:pc="http://schemas.microsoft.com/office/infopath/2007/PartnerControls">
   <documentManagement>
@@ -17910,14 +17933,6 @@
 </file>
 
 <file path=customXml/itemProps1.xml><?xml version="1.0" encoding="utf-8"?>
-<ds:datastoreItem xmlns:ds="http://schemas.openxmlformats.org/officeDocument/2006/customXml" ds:itemID="{B579702B-25C7-40D7-9E29-7686B11A9660}">
-  <ds:schemaRefs>
-    <ds:schemaRef ds:uri="http://schemas.microsoft.com/sharepoint/v3/contenttype/forms"/>
-  </ds:schemaRefs>
-</ds:datastoreItem>
-</file>
-
-<file path=customXml/itemProps2.xml><?xml version="1.0" encoding="utf-8"?>
 <ds:datastoreItem xmlns:ds="http://schemas.openxmlformats.org/officeDocument/2006/customXml" ds:itemID="{A7C0B241-13E5-418D-8920-D23491E2D2C0}">
   <ds:schemaRefs>
     <ds:schemaRef ds:uri="http://schemas.microsoft.com/office/2006/metadata/contentType"/>
@@ -17936,6 +17951,14 @@
 </ds:datastoreItem>
 </file>
 
+<file path=customXml/itemProps2.xml><?xml version="1.0" encoding="utf-8"?>
+<ds:datastoreItem xmlns:ds="http://schemas.openxmlformats.org/officeDocument/2006/customXml" ds:itemID="{B579702B-25C7-40D7-9E29-7686B11A9660}">
+  <ds:schemaRefs>
+    <ds:schemaRef ds:uri="http://schemas.microsoft.com/sharepoint/v3/contenttype/forms"/>
+  </ds:schemaRefs>
+</ds:datastoreItem>
+</file>
+
 <file path=customXml/itemProps3.xml><?xml version="1.0" encoding="utf-8"?>
 <ds:datastoreItem xmlns:ds="http://schemas.openxmlformats.org/officeDocument/2006/customXml" ds:itemID="{E7866CFD-F94E-4AE5-ACEA-86FEC0F48A10}">
   <ds:schemaRefs>

</xml_diff>